<commit_message>
perf+refactor: migration data.js -> data-loader.js async sur tout le site
- Supprimer l'inclusion synchrone de js/data.js dans 1386 pages (seul
  index.html consomme les données)
- index.html: charger js/data-loader.js (defer) + rendu des actualités
  après l'événement 'data-loaded' (window.NEWS_DATA)
- data-loader.js: chemin dérivé de currentScript.src (compatible
  GitHub Pages sous-projet), émission de l'événement même en cas d'échec
- Convertir 5200+ références /images/... absolues en chemins relatifs
  (régression cassant le déploiement GH Pages en sous-dossier)
- Conserver lazy-loading + dimensions images + ancres #news du chantier
  précédent
- Supprimer FIGURES/Module TIC.png (aucune référence)
</commit_message>
<xml_diff>
--- a/cours/Module TIC/Département Anglais/ENS 1ère année/Cours_TIC_01_Introduction_aux_TIC_EN.pptx
+++ b/cours/Module TIC/Département Anglais/ENS 1ère année/Cours_TIC_01_Introduction_aux_TIC_EN.pptx
@@ -4,9 +4,6 @@
   <p:sldMasterIdLst>
     <p:sldMasterId id="2147483648" r:id="rId1"/>
   </p:sldMasterIdLst>
-  <p:notesMasterIdLst>
-    <p:notesMasterId r:id="rId33"/>
-  </p:notesMasterIdLst>
   <p:sldIdLst>
     <p:sldId id="256" r:id="rId7"/>
     <p:sldId id="257" r:id="rId8"/>
@@ -18,6 +15,11 @@
     <p:sldId id="263" r:id="rId14"/>
     <p:sldId id="264" r:id="rId15"/>
     <p:sldId id="265" r:id="rId16"/>
+    <p:sldId id="266" r:id="rId17"/>
+    <p:sldId id="267" r:id="rId18"/>
+    <p:sldId id="268" r:id="rId19"/>
+    <p:sldId id="269" r:id="rId20"/>
+    <p:sldId id="270" r:id="rId21"/>
   </p:sldIdLst>
   <p:sldSz cx="9144000" cy="6858000" type="screen4x3"/>
   <p:notesSz cx="6858000" cy="9144000"/>
@@ -116,372 +118,7 @@
       </a:defRPr>
     </a:lvl9pPr>
   </p:defaultTextStyle>
-  <p:extLst>
-    <p:ext uri="{EFAFB233-063F-42B5-8137-9DF3F51BA10A}">
-      <p15:sldGuideLst xmlns:p15="http://schemas.microsoft.com/office/powerpoint/2012/main">
-        <p15:guide id="1" orient="horz" pos="2160">
-          <p15:clr>
-            <a:srgbClr val="A4A3A4"/>
-          </p15:clr>
-        </p15:guide>
-        <p15:guide id="2" pos="2880">
-          <p15:clr>
-            <a:srgbClr val="A4A3A4"/>
-          </p15:clr>
-        </p15:guide>
-      </p15:sldGuideLst>
-    </p:ext>
-  </p:extLst>
 </p:presentation>
-</file>
-
-<file path=ppt/notesMasters/notesMaster1.xml><?xml version="1.0" encoding="utf-8"?>
-<p:notesMaster xmlns:a="http://schemas.openxmlformats.org/drawingml/2006/main" xmlns:r="http://schemas.openxmlformats.org/officeDocument/2006/relationships" xmlns:p="http://schemas.openxmlformats.org/presentationml/2006/main">
-  <p:cSld>
-    <p:bg>
-      <p:bgRef idx="1001">
-        <a:schemeClr val="bg1"/>
-      </p:bgRef>
-    </p:bg>
-    <p:spTree>
-      <p:nvGrpSpPr>
-        <p:cNvPr id="1" name=""/>
-        <p:cNvGrpSpPr/>
-        <p:nvPr/>
-      </p:nvGrpSpPr>
-      <p:grpSpPr>
-        <a:xfrm>
-          <a:off x="0" y="0"/>
-          <a:ext cx="0" cy="0"/>
-          <a:chOff x="0" y="0"/>
-          <a:chExt cx="0" cy="0"/>
-        </a:xfrm>
-      </p:grpSpPr>
-      <p:sp>
-        <p:nvSpPr>
-          <p:cNvPr id="2" name="Espace réservé de l'en-tête 1"/>
-          <p:cNvSpPr>
-            <a:spLocks noGrp="1"/>
-          </p:cNvSpPr>
-          <p:nvPr>
-            <p:ph type="hdr" sz="quarter"/>
-          </p:nvPr>
-        </p:nvSpPr>
-        <p:spPr>
-          <a:xfrm>
-            <a:off x="0" y="0"/>
-            <a:ext cx="2971800" cy="458788"/>
-          </a:xfrm>
-          <a:prstGeom prst="rect">
-            <a:avLst/>
-          </a:prstGeom>
-        </p:spPr>
-        <p:txBody>
-          <a:bodyPr vert="horz" lIns="91440" tIns="45720" rIns="91440" bIns="45720" rtlCol="0"/>
-          <a:lstStyle>
-            <a:lvl1pPr algn="l">
-              <a:defRPr sz="1200"/>
-            </a:lvl1pPr>
-          </a:lstStyle>
-          <a:p>
-            <a:endParaRPr lang="fr-FR"/>
-          </a:p>
-        </p:txBody>
-      </p:sp>
-      <p:sp>
-        <p:nvSpPr>
-          <p:cNvPr id="3" name="Espace réservé de la date 2"/>
-          <p:cNvSpPr>
-            <a:spLocks noGrp="1"/>
-          </p:cNvSpPr>
-          <p:nvPr>
-            <p:ph type="dt" idx="1"/>
-          </p:nvPr>
-        </p:nvSpPr>
-        <p:spPr>
-          <a:xfrm>
-            <a:off x="3884613" y="0"/>
-            <a:ext cx="2971800" cy="458788"/>
-          </a:xfrm>
-          <a:prstGeom prst="rect">
-            <a:avLst/>
-          </a:prstGeom>
-        </p:spPr>
-        <p:txBody>
-          <a:bodyPr vert="horz" lIns="91440" tIns="45720" rIns="91440" bIns="45720" rtlCol="0"/>
-          <a:lstStyle>
-            <a:lvl1pPr algn="r">
-              <a:defRPr sz="1200"/>
-            </a:lvl1pPr>
-          </a:lstStyle>
-          <a:p>
-            <a:fld id="{B8F0B2C1-4194-45A7-9834-731A4F36BABD}" type="datetimeFigureOut">
-              <a:rPr lang="fr-FR" smtClean="0"/>
-              <a:t>16/05/2026</a:t>
-            </a:fld>
-            <a:endParaRPr lang="fr-FR"/>
-          </a:p>
-        </p:txBody>
-      </p:sp>
-      <p:sp>
-        <p:nvSpPr>
-          <p:cNvPr id="4" name="Espace réservé de l'image des diapositives 3"/>
-          <p:cNvSpPr>
-            <a:spLocks noGrp="1" noRot="1" noChangeAspect="1"/>
-          </p:cNvSpPr>
-          <p:nvPr>
-            <p:ph type="sldImg" idx="2"/>
-          </p:nvPr>
-        </p:nvSpPr>
-        <p:spPr>
-          <a:xfrm>
-            <a:off x="1371600" y="1143000"/>
-            <a:ext cx="4114800" cy="3086100"/>
-          </a:xfrm>
-          <a:prstGeom prst="rect">
-            <a:avLst/>
-          </a:prstGeom>
-          <a:noFill/>
-          <a:ln w="12700">
-            <a:solidFill>
-              <a:prstClr val="black"/>
-            </a:solidFill>
-          </a:ln>
-        </p:spPr>
-        <p:txBody>
-          <a:bodyPr vert="horz" lIns="91440" tIns="45720" rIns="91440" bIns="45720" rtlCol="0" anchor="ctr"/>
-          <a:lstStyle/>
-          <a:p>
-            <a:endParaRPr lang="fr-FR"/>
-          </a:p>
-        </p:txBody>
-      </p:sp>
-      <p:sp>
-        <p:nvSpPr>
-          <p:cNvPr id="5" name="Espace réservé des notes 4"/>
-          <p:cNvSpPr>
-            <a:spLocks noGrp="1"/>
-          </p:cNvSpPr>
-          <p:nvPr>
-            <p:ph type="body" sz="quarter" idx="3"/>
-          </p:nvPr>
-        </p:nvSpPr>
-        <p:spPr>
-          <a:xfrm>
-            <a:off x="685800" y="4400550"/>
-            <a:ext cx="5486400" cy="3600450"/>
-          </a:xfrm>
-          <a:prstGeom prst="rect">
-            <a:avLst/>
-          </a:prstGeom>
-        </p:spPr>
-        <p:txBody>
-          <a:bodyPr vert="horz" lIns="91440" tIns="45720" rIns="91440" bIns="45720" rtlCol="0"/>
-          <a:lstStyle/>
-          <a:p>
-            <a:pPr lvl="0"/>
-            <a:r>
-              <a:rPr lang="fr-FR"/>
-              <a:t>Cliquez pour modifier les styles du texte du masque</a:t>
-            </a:r>
-          </a:p>
-          <a:p>
-            <a:pPr lvl="1"/>
-            <a:r>
-              <a:rPr lang="fr-FR"/>
-              <a:t>Deuxième niveau</a:t>
-            </a:r>
-          </a:p>
-          <a:p>
-            <a:pPr lvl="2"/>
-            <a:r>
-              <a:rPr lang="fr-FR"/>
-              <a:t>Troisième niveau</a:t>
-            </a:r>
-          </a:p>
-          <a:p>
-            <a:pPr lvl="3"/>
-            <a:r>
-              <a:rPr lang="fr-FR"/>
-              <a:t>Quatrième niveau</a:t>
-            </a:r>
-          </a:p>
-          <a:p>
-            <a:pPr lvl="4"/>
-            <a:r>
-              <a:rPr lang="fr-FR"/>
-              <a:t>Cinquième niveau</a:t>
-            </a:r>
-          </a:p>
-        </p:txBody>
-      </p:sp>
-      <p:sp>
-        <p:nvSpPr>
-          <p:cNvPr id="6" name="Espace réservé du pied de page 5"/>
-          <p:cNvSpPr>
-            <a:spLocks noGrp="1"/>
-          </p:cNvSpPr>
-          <p:nvPr>
-            <p:ph type="ftr" sz="quarter" idx="4"/>
-          </p:nvPr>
-        </p:nvSpPr>
-        <p:spPr>
-          <a:xfrm>
-            <a:off x="0" y="8685213"/>
-            <a:ext cx="2971800" cy="458787"/>
-          </a:xfrm>
-          <a:prstGeom prst="rect">
-            <a:avLst/>
-          </a:prstGeom>
-        </p:spPr>
-        <p:txBody>
-          <a:bodyPr vert="horz" lIns="91440" tIns="45720" rIns="91440" bIns="45720" rtlCol="0" anchor="b"/>
-          <a:lstStyle>
-            <a:lvl1pPr algn="l">
-              <a:defRPr sz="1200"/>
-            </a:lvl1pPr>
-          </a:lstStyle>
-          <a:p>
-            <a:endParaRPr lang="fr-FR"/>
-          </a:p>
-        </p:txBody>
-      </p:sp>
-      <p:sp>
-        <p:nvSpPr>
-          <p:cNvPr id="7" name="Espace réservé du numéro de diapositive 6"/>
-          <p:cNvSpPr>
-            <a:spLocks noGrp="1"/>
-          </p:cNvSpPr>
-          <p:nvPr>
-            <p:ph type="sldNum" sz="quarter" idx="5"/>
-          </p:nvPr>
-        </p:nvSpPr>
-        <p:spPr>
-          <a:xfrm>
-            <a:off x="3884613" y="8685213"/>
-            <a:ext cx="2971800" cy="458787"/>
-          </a:xfrm>
-          <a:prstGeom prst="rect">
-            <a:avLst/>
-          </a:prstGeom>
-        </p:spPr>
-        <p:txBody>
-          <a:bodyPr vert="horz" lIns="91440" tIns="45720" rIns="91440" bIns="45720" rtlCol="0" anchor="b"/>
-          <a:lstStyle>
-            <a:lvl1pPr algn="r">
-              <a:defRPr sz="1200"/>
-            </a:lvl1pPr>
-          </a:lstStyle>
-          <a:p>
-            <a:fld id="{EDB5666F-E79B-4A29-9A64-FA4855FAABBD}" type="slidenum">
-              <a:rPr lang="fr-FR" smtClean="0"/>
-              <a:t>‹N°›</a:t>
-            </a:fld>
-            <a:endParaRPr lang="fr-FR"/>
-          </a:p>
-        </p:txBody>
-      </p:sp>
-    </p:spTree>
-    <p:extLst>
-      <p:ext uri="{BB962C8B-B14F-4D97-AF65-F5344CB8AC3E}">
-        <p14:creationId xmlns:p14="http://schemas.microsoft.com/office/powerpoint/2010/main" val="4057233482"/>
-      </p:ext>
-    </p:extLst>
-  </p:cSld>
-  <p:clrMap bg1="lt1" tx1="dk1" bg2="lt2" tx2="dk2" accent1="accent1" accent2="accent2" accent3="accent3" accent4="accent4" accent5="accent5" accent6="accent6" hlink="hlink" folHlink="folHlink"/>
-  <p:notesStyle>
-    <a:lvl1pPr marL="0" algn="l" defTabSz="914400" rtl="0" eaLnBrk="1" latinLnBrk="0" hangingPunct="1">
-      <a:defRPr sz="1200" kern="1200">
-        <a:solidFill>
-          <a:schemeClr val="tx1"/>
-        </a:solidFill>
-        <a:latin typeface="+mn-lt"/>
-        <a:ea typeface="+mn-ea"/>
-        <a:cs typeface="+mn-cs"/>
-      </a:defRPr>
-    </a:lvl1pPr>
-    <a:lvl2pPr marL="457200" algn="l" defTabSz="914400" rtl="0" eaLnBrk="1" latinLnBrk="0" hangingPunct="1">
-      <a:defRPr sz="1200" kern="1200">
-        <a:solidFill>
-          <a:schemeClr val="tx1"/>
-        </a:solidFill>
-        <a:latin typeface="+mn-lt"/>
-        <a:ea typeface="+mn-ea"/>
-        <a:cs typeface="+mn-cs"/>
-      </a:defRPr>
-    </a:lvl2pPr>
-    <a:lvl3pPr marL="914400" algn="l" defTabSz="914400" rtl="0" eaLnBrk="1" latinLnBrk="0" hangingPunct="1">
-      <a:defRPr sz="1200" kern="1200">
-        <a:solidFill>
-          <a:schemeClr val="tx1"/>
-        </a:solidFill>
-        <a:latin typeface="+mn-lt"/>
-        <a:ea typeface="+mn-ea"/>
-        <a:cs typeface="+mn-cs"/>
-      </a:defRPr>
-    </a:lvl3pPr>
-    <a:lvl4pPr marL="1371600" algn="l" defTabSz="914400" rtl="0" eaLnBrk="1" latinLnBrk="0" hangingPunct="1">
-      <a:defRPr sz="1200" kern="1200">
-        <a:solidFill>
-          <a:schemeClr val="tx1"/>
-        </a:solidFill>
-        <a:latin typeface="+mn-lt"/>
-        <a:ea typeface="+mn-ea"/>
-        <a:cs typeface="+mn-cs"/>
-      </a:defRPr>
-    </a:lvl4pPr>
-    <a:lvl5pPr marL="1828800" algn="l" defTabSz="914400" rtl="0" eaLnBrk="1" latinLnBrk="0" hangingPunct="1">
-      <a:defRPr sz="1200" kern="1200">
-        <a:solidFill>
-          <a:schemeClr val="tx1"/>
-        </a:solidFill>
-        <a:latin typeface="+mn-lt"/>
-        <a:ea typeface="+mn-ea"/>
-        <a:cs typeface="+mn-cs"/>
-      </a:defRPr>
-    </a:lvl5pPr>
-    <a:lvl6pPr marL="2286000" algn="l" defTabSz="914400" rtl="0" eaLnBrk="1" latinLnBrk="0" hangingPunct="1">
-      <a:defRPr sz="1200" kern="1200">
-        <a:solidFill>
-          <a:schemeClr val="tx1"/>
-        </a:solidFill>
-        <a:latin typeface="+mn-lt"/>
-        <a:ea typeface="+mn-ea"/>
-        <a:cs typeface="+mn-cs"/>
-      </a:defRPr>
-    </a:lvl6pPr>
-    <a:lvl7pPr marL="2743200" algn="l" defTabSz="914400" rtl="0" eaLnBrk="1" latinLnBrk="0" hangingPunct="1">
-      <a:defRPr sz="1200" kern="1200">
-        <a:solidFill>
-          <a:schemeClr val="tx1"/>
-        </a:solidFill>
-        <a:latin typeface="+mn-lt"/>
-        <a:ea typeface="+mn-ea"/>
-        <a:cs typeface="+mn-cs"/>
-      </a:defRPr>
-    </a:lvl7pPr>
-    <a:lvl8pPr marL="3200400" algn="l" defTabSz="914400" rtl="0" eaLnBrk="1" latinLnBrk="0" hangingPunct="1">
-      <a:defRPr sz="1200" kern="1200">
-        <a:solidFill>
-          <a:schemeClr val="tx1"/>
-        </a:solidFill>
-        <a:latin typeface="+mn-lt"/>
-        <a:ea typeface="+mn-ea"/>
-        <a:cs typeface="+mn-cs"/>
-      </a:defRPr>
-    </a:lvl8pPr>
-    <a:lvl9pPr marL="3657600" algn="l" defTabSz="914400" rtl="0" eaLnBrk="1" latinLnBrk="0" hangingPunct="1">
-      <a:defRPr sz="1200" kern="1200">
-        <a:solidFill>
-          <a:schemeClr val="tx1"/>
-        </a:solidFill>
-        <a:latin typeface="+mn-lt"/>
-        <a:ea typeface="+mn-ea"/>
-        <a:cs typeface="+mn-cs"/>
-      </a:defRPr>
-    </a:lvl9pPr>
-  </p:notesStyle>
-</p:notesMaster>
 </file>
 
 <file path=ppt/slideLayouts/slideLayout1.xml><?xml version="1.0" encoding="utf-8"?>
@@ -522,9 +159,10 @@
           <a:lstStyle/>
           <a:p>
             <a:r>
-              <a:rPr lang="en-US"/>
+              <a:rPr lang="en-US" smtClean="0"/>
               <a:t>Click to edit Master title style</a:t>
             </a:r>
+            <a:endParaRPr lang="en-US"/>
           </a:p>
         </p:txBody>
       </p:sp>
@@ -640,9 +278,10 @@
           </a:lstStyle>
           <a:p>
             <a:r>
-              <a:rPr lang="en-US"/>
+              <a:rPr lang="en-US" smtClean="0"/>
               <a:t>Click to edit Master subtitle style</a:t>
             </a:r>
+            <a:endParaRPr lang="en-US"/>
           </a:p>
         </p:txBody>
       </p:sp>
@@ -663,7 +302,7 @@
           <a:p>
             <a:fld id="{5BCAD085-E8A6-8845-BD4E-CB4CCA059FC4}" type="datetimeFigureOut">
               <a:rPr lang="en-US" smtClean="0"/>
-              <a:t>5/16/2026</a:t>
+              <a:t>1/27/13</a:t>
             </a:fld>
             <a:endParaRPr lang="en-US"/>
           </a:p>
@@ -705,7 +344,7 @@
           <a:p>
             <a:fld id="{C1FF6DA9-008F-8B48-92A6-B652298478BF}" type="slidenum">
               <a:rPr lang="en-US" smtClean="0"/>
-              <a:t>‹N°›</a:t>
+              <a:t>‹#›</a:t>
             </a:fld>
             <a:endParaRPr lang="en-US"/>
           </a:p>
@@ -757,9 +396,10 @@
           <a:lstStyle/>
           <a:p>
             <a:r>
-              <a:rPr lang="en-US"/>
+              <a:rPr lang="en-US" smtClean="0"/>
               <a:t>Click to edit Master title style</a:t>
             </a:r>
+            <a:endParaRPr lang="en-US"/>
           </a:p>
         </p:txBody>
       </p:sp>
@@ -780,37 +420,38 @@
           <a:p>
             <a:pPr lvl="0"/>
             <a:r>
-              <a:rPr lang="en-US"/>
+              <a:rPr lang="en-US" smtClean="0"/>
               <a:t>Click to edit Master text styles</a:t>
             </a:r>
           </a:p>
           <a:p>
             <a:pPr lvl="1"/>
             <a:r>
-              <a:rPr lang="en-US"/>
+              <a:rPr lang="en-US" smtClean="0"/>
               <a:t>Second level</a:t>
             </a:r>
           </a:p>
           <a:p>
             <a:pPr lvl="2"/>
             <a:r>
-              <a:rPr lang="en-US"/>
+              <a:rPr lang="en-US" smtClean="0"/>
               <a:t>Third level</a:t>
             </a:r>
           </a:p>
           <a:p>
             <a:pPr lvl="3"/>
             <a:r>
-              <a:rPr lang="en-US"/>
+              <a:rPr lang="en-US" smtClean="0"/>
               <a:t>Fourth level</a:t>
             </a:r>
           </a:p>
           <a:p>
             <a:pPr lvl="4"/>
             <a:r>
-              <a:rPr lang="en-US"/>
+              <a:rPr lang="en-US" smtClean="0"/>
               <a:t>Fifth level</a:t>
             </a:r>
+            <a:endParaRPr lang="en-US"/>
           </a:p>
         </p:txBody>
       </p:sp>
@@ -831,7 +472,7 @@
           <a:p>
             <a:fld id="{5BCAD085-E8A6-8845-BD4E-CB4CCA059FC4}" type="datetimeFigureOut">
               <a:rPr lang="en-US" smtClean="0"/>
-              <a:t>5/16/2026</a:t>
+              <a:t>1/27/13</a:t>
             </a:fld>
             <a:endParaRPr lang="en-US"/>
           </a:p>
@@ -873,7 +514,7 @@
           <a:p>
             <a:fld id="{C1FF6DA9-008F-8B48-92A6-B652298478BF}" type="slidenum">
               <a:rPr lang="en-US" smtClean="0"/>
-              <a:t>‹N°›</a:t>
+              <a:t>‹#›</a:t>
             </a:fld>
             <a:endParaRPr lang="en-US"/>
           </a:p>
@@ -930,9 +571,10 @@
           <a:lstStyle/>
           <a:p>
             <a:r>
-              <a:rPr lang="en-US"/>
+              <a:rPr lang="en-US" smtClean="0"/>
               <a:t>Click to edit Master title style</a:t>
             </a:r>
+            <a:endParaRPr lang="en-US"/>
           </a:p>
         </p:txBody>
       </p:sp>
@@ -958,37 +600,38 @@
           <a:p>
             <a:pPr lvl="0"/>
             <a:r>
-              <a:rPr lang="en-US"/>
+              <a:rPr lang="en-US" smtClean="0"/>
               <a:t>Click to edit Master text styles</a:t>
             </a:r>
           </a:p>
           <a:p>
             <a:pPr lvl="1"/>
             <a:r>
-              <a:rPr lang="en-US"/>
+              <a:rPr lang="en-US" smtClean="0"/>
               <a:t>Second level</a:t>
             </a:r>
           </a:p>
           <a:p>
             <a:pPr lvl="2"/>
             <a:r>
-              <a:rPr lang="en-US"/>
+              <a:rPr lang="en-US" smtClean="0"/>
               <a:t>Third level</a:t>
             </a:r>
           </a:p>
           <a:p>
             <a:pPr lvl="3"/>
             <a:r>
-              <a:rPr lang="en-US"/>
+              <a:rPr lang="en-US" smtClean="0"/>
               <a:t>Fourth level</a:t>
             </a:r>
           </a:p>
           <a:p>
             <a:pPr lvl="4"/>
             <a:r>
-              <a:rPr lang="en-US"/>
+              <a:rPr lang="en-US" smtClean="0"/>
               <a:t>Fifth level</a:t>
             </a:r>
+            <a:endParaRPr lang="en-US"/>
           </a:p>
         </p:txBody>
       </p:sp>
@@ -1009,7 +652,7 @@
           <a:p>
             <a:fld id="{5BCAD085-E8A6-8845-BD4E-CB4CCA059FC4}" type="datetimeFigureOut">
               <a:rPr lang="en-US" smtClean="0"/>
-              <a:t>5/16/2026</a:t>
+              <a:t>1/27/13</a:t>
             </a:fld>
             <a:endParaRPr lang="en-US"/>
           </a:p>
@@ -1051,7 +694,7 @@
           <a:p>
             <a:fld id="{C1FF6DA9-008F-8B48-92A6-B652298478BF}" type="slidenum">
               <a:rPr lang="en-US" smtClean="0"/>
-              <a:t>‹N°›</a:t>
+              <a:t>‹#›</a:t>
             </a:fld>
             <a:endParaRPr lang="en-US"/>
           </a:p>
@@ -1103,9 +746,10 @@
           <a:lstStyle/>
           <a:p>
             <a:r>
-              <a:rPr lang="en-US"/>
+              <a:rPr lang="en-US" smtClean="0"/>
               <a:t>Click to edit Master title style</a:t>
             </a:r>
+            <a:endParaRPr lang="en-US"/>
           </a:p>
         </p:txBody>
       </p:sp>
@@ -1126,37 +770,38 @@
           <a:p>
             <a:pPr lvl="0"/>
             <a:r>
-              <a:rPr lang="en-US"/>
+              <a:rPr lang="en-US" smtClean="0"/>
               <a:t>Click to edit Master text styles</a:t>
             </a:r>
           </a:p>
           <a:p>
             <a:pPr lvl="1"/>
             <a:r>
-              <a:rPr lang="en-US"/>
+              <a:rPr lang="en-US" smtClean="0"/>
               <a:t>Second level</a:t>
             </a:r>
           </a:p>
           <a:p>
             <a:pPr lvl="2"/>
             <a:r>
-              <a:rPr lang="en-US"/>
+              <a:rPr lang="en-US" smtClean="0"/>
               <a:t>Third level</a:t>
             </a:r>
           </a:p>
           <a:p>
             <a:pPr lvl="3"/>
             <a:r>
-              <a:rPr lang="en-US"/>
+              <a:rPr lang="en-US" smtClean="0"/>
               <a:t>Fourth level</a:t>
             </a:r>
           </a:p>
           <a:p>
             <a:pPr lvl="4"/>
             <a:r>
-              <a:rPr lang="en-US"/>
+              <a:rPr lang="en-US" smtClean="0"/>
               <a:t>Fifth level</a:t>
             </a:r>
+            <a:endParaRPr lang="en-US"/>
           </a:p>
         </p:txBody>
       </p:sp>
@@ -1177,7 +822,7 @@
           <a:p>
             <a:fld id="{5BCAD085-E8A6-8845-BD4E-CB4CCA059FC4}" type="datetimeFigureOut">
               <a:rPr lang="en-US" smtClean="0"/>
-              <a:t>5/16/2026</a:t>
+              <a:t>1/27/13</a:t>
             </a:fld>
             <a:endParaRPr lang="en-US"/>
           </a:p>
@@ -1219,7 +864,7 @@
           <a:p>
             <a:fld id="{C1FF6DA9-008F-8B48-92A6-B652298478BF}" type="slidenum">
               <a:rPr lang="en-US" smtClean="0"/>
-              <a:t>‹N°›</a:t>
+              <a:t>‹#›</a:t>
             </a:fld>
             <a:endParaRPr lang="en-US"/>
           </a:p>
@@ -1280,9 +925,10 @@
           </a:lstStyle>
           <a:p>
             <a:r>
-              <a:rPr lang="en-US"/>
+              <a:rPr lang="en-US" smtClean="0"/>
               <a:t>Click to edit Master title style</a:t>
             </a:r>
+            <a:endParaRPr lang="en-US"/>
           </a:p>
         </p:txBody>
       </p:sp>
@@ -1399,7 +1045,7 @@
           <a:p>
             <a:pPr lvl="0"/>
             <a:r>
-              <a:rPr lang="en-US"/>
+              <a:rPr lang="en-US" smtClean="0"/>
               <a:t>Click to edit Master text styles</a:t>
             </a:r>
           </a:p>
@@ -1422,7 +1068,7 @@
           <a:p>
             <a:fld id="{5BCAD085-E8A6-8845-BD4E-CB4CCA059FC4}" type="datetimeFigureOut">
               <a:rPr lang="en-US" smtClean="0"/>
-              <a:t>5/16/2026</a:t>
+              <a:t>1/27/13</a:t>
             </a:fld>
             <a:endParaRPr lang="en-US"/>
           </a:p>
@@ -1464,7 +1110,7 @@
           <a:p>
             <a:fld id="{C1FF6DA9-008F-8B48-92A6-B652298478BF}" type="slidenum">
               <a:rPr lang="en-US" smtClean="0"/>
-              <a:t>‹N°›</a:t>
+              <a:t>‹#›</a:t>
             </a:fld>
             <a:endParaRPr lang="en-US"/>
           </a:p>
@@ -1516,9 +1162,10 @@
           <a:lstStyle/>
           <a:p>
             <a:r>
-              <a:rPr lang="en-US"/>
+              <a:rPr lang="en-US" smtClean="0"/>
               <a:t>Click to edit Master title style</a:t>
             </a:r>
+            <a:endParaRPr lang="en-US"/>
           </a:p>
         </p:txBody>
       </p:sp>
@@ -1572,37 +1219,38 @@
           <a:p>
             <a:pPr lvl="0"/>
             <a:r>
-              <a:rPr lang="en-US"/>
+              <a:rPr lang="en-US" smtClean="0"/>
               <a:t>Click to edit Master text styles</a:t>
             </a:r>
           </a:p>
           <a:p>
             <a:pPr lvl="1"/>
             <a:r>
-              <a:rPr lang="en-US"/>
+              <a:rPr lang="en-US" smtClean="0"/>
               <a:t>Second level</a:t>
             </a:r>
           </a:p>
           <a:p>
             <a:pPr lvl="2"/>
             <a:r>
-              <a:rPr lang="en-US"/>
+              <a:rPr lang="en-US" smtClean="0"/>
               <a:t>Third level</a:t>
             </a:r>
           </a:p>
           <a:p>
             <a:pPr lvl="3"/>
             <a:r>
-              <a:rPr lang="en-US"/>
+              <a:rPr lang="en-US" smtClean="0"/>
               <a:t>Fourth level</a:t>
             </a:r>
           </a:p>
           <a:p>
             <a:pPr lvl="4"/>
             <a:r>
-              <a:rPr lang="en-US"/>
+              <a:rPr lang="en-US" smtClean="0"/>
               <a:t>Fifth level</a:t>
             </a:r>
+            <a:endParaRPr lang="en-US"/>
           </a:p>
         </p:txBody>
       </p:sp>
@@ -1656,37 +1304,38 @@
           <a:p>
             <a:pPr lvl="0"/>
             <a:r>
-              <a:rPr lang="en-US"/>
+              <a:rPr lang="en-US" smtClean="0"/>
               <a:t>Click to edit Master text styles</a:t>
             </a:r>
           </a:p>
           <a:p>
             <a:pPr lvl="1"/>
             <a:r>
-              <a:rPr lang="en-US"/>
+              <a:rPr lang="en-US" smtClean="0"/>
               <a:t>Second level</a:t>
             </a:r>
           </a:p>
           <a:p>
             <a:pPr lvl="2"/>
             <a:r>
-              <a:rPr lang="en-US"/>
+              <a:rPr lang="en-US" smtClean="0"/>
               <a:t>Third level</a:t>
             </a:r>
           </a:p>
           <a:p>
             <a:pPr lvl="3"/>
             <a:r>
-              <a:rPr lang="en-US"/>
+              <a:rPr lang="en-US" smtClean="0"/>
               <a:t>Fourth level</a:t>
             </a:r>
           </a:p>
           <a:p>
             <a:pPr lvl="4"/>
             <a:r>
-              <a:rPr lang="en-US"/>
+              <a:rPr lang="en-US" smtClean="0"/>
               <a:t>Fifth level</a:t>
             </a:r>
+            <a:endParaRPr lang="en-US"/>
           </a:p>
         </p:txBody>
       </p:sp>
@@ -1707,7 +1356,7 @@
           <a:p>
             <a:fld id="{5BCAD085-E8A6-8845-BD4E-CB4CCA059FC4}" type="datetimeFigureOut">
               <a:rPr lang="en-US" smtClean="0"/>
-              <a:t>5/16/2026</a:t>
+              <a:t>1/27/13</a:t>
             </a:fld>
             <a:endParaRPr lang="en-US"/>
           </a:p>
@@ -1749,7 +1398,7 @@
           <a:p>
             <a:fld id="{C1FF6DA9-008F-8B48-92A6-B652298478BF}" type="slidenum">
               <a:rPr lang="en-US" smtClean="0"/>
-              <a:t>‹N°›</a:t>
+              <a:t>‹#›</a:t>
             </a:fld>
             <a:endParaRPr lang="en-US"/>
           </a:p>
@@ -1805,9 +1454,10 @@
           </a:lstStyle>
           <a:p>
             <a:r>
-              <a:rPr lang="en-US"/>
+              <a:rPr lang="en-US" smtClean="0"/>
               <a:t>Click to edit Master title style</a:t>
             </a:r>
+            <a:endParaRPr lang="en-US"/>
           </a:p>
         </p:txBody>
       </p:sp>
@@ -1870,7 +1520,7 @@
           <a:p>
             <a:pPr lvl="0"/>
             <a:r>
-              <a:rPr lang="en-US"/>
+              <a:rPr lang="en-US" smtClean="0"/>
               <a:t>Click to edit Master text styles</a:t>
             </a:r>
           </a:p>
@@ -1926,37 +1576,38 @@
           <a:p>
             <a:pPr lvl="0"/>
             <a:r>
-              <a:rPr lang="en-US"/>
+              <a:rPr lang="en-US" smtClean="0"/>
               <a:t>Click to edit Master text styles</a:t>
             </a:r>
           </a:p>
           <a:p>
             <a:pPr lvl="1"/>
             <a:r>
-              <a:rPr lang="en-US"/>
+              <a:rPr lang="en-US" smtClean="0"/>
               <a:t>Second level</a:t>
             </a:r>
           </a:p>
           <a:p>
             <a:pPr lvl="2"/>
             <a:r>
-              <a:rPr lang="en-US"/>
+              <a:rPr lang="en-US" smtClean="0"/>
               <a:t>Third level</a:t>
             </a:r>
           </a:p>
           <a:p>
             <a:pPr lvl="3"/>
             <a:r>
-              <a:rPr lang="en-US"/>
+              <a:rPr lang="en-US" smtClean="0"/>
               <a:t>Fourth level</a:t>
             </a:r>
           </a:p>
           <a:p>
             <a:pPr lvl="4"/>
             <a:r>
-              <a:rPr lang="en-US"/>
+              <a:rPr lang="en-US" smtClean="0"/>
               <a:t>Fifth level</a:t>
             </a:r>
+            <a:endParaRPr lang="en-US"/>
           </a:p>
         </p:txBody>
       </p:sp>
@@ -2019,7 +1670,7 @@
           <a:p>
             <a:pPr lvl="0"/>
             <a:r>
-              <a:rPr lang="en-US"/>
+              <a:rPr lang="en-US" smtClean="0"/>
               <a:t>Click to edit Master text styles</a:t>
             </a:r>
           </a:p>
@@ -2075,37 +1726,38 @@
           <a:p>
             <a:pPr lvl="0"/>
             <a:r>
-              <a:rPr lang="en-US"/>
+              <a:rPr lang="en-US" smtClean="0"/>
               <a:t>Click to edit Master text styles</a:t>
             </a:r>
           </a:p>
           <a:p>
             <a:pPr lvl="1"/>
             <a:r>
-              <a:rPr lang="en-US"/>
+              <a:rPr lang="en-US" smtClean="0"/>
               <a:t>Second level</a:t>
             </a:r>
           </a:p>
           <a:p>
             <a:pPr lvl="2"/>
             <a:r>
-              <a:rPr lang="en-US"/>
+              <a:rPr lang="en-US" smtClean="0"/>
               <a:t>Third level</a:t>
             </a:r>
           </a:p>
           <a:p>
             <a:pPr lvl="3"/>
             <a:r>
-              <a:rPr lang="en-US"/>
+              <a:rPr lang="en-US" smtClean="0"/>
               <a:t>Fourth level</a:t>
             </a:r>
           </a:p>
           <a:p>
             <a:pPr lvl="4"/>
             <a:r>
-              <a:rPr lang="en-US"/>
+              <a:rPr lang="en-US" smtClean="0"/>
               <a:t>Fifth level</a:t>
             </a:r>
+            <a:endParaRPr lang="en-US"/>
           </a:p>
         </p:txBody>
       </p:sp>
@@ -2126,7 +1778,7 @@
           <a:p>
             <a:fld id="{5BCAD085-E8A6-8845-BD4E-CB4CCA059FC4}" type="datetimeFigureOut">
               <a:rPr lang="en-US" smtClean="0"/>
-              <a:t>5/16/2026</a:t>
+              <a:t>1/27/13</a:t>
             </a:fld>
             <a:endParaRPr lang="en-US"/>
           </a:p>
@@ -2168,7 +1820,7 @@
           <a:p>
             <a:fld id="{C1FF6DA9-008F-8B48-92A6-B652298478BF}" type="slidenum">
               <a:rPr lang="en-US" smtClean="0"/>
-              <a:t>‹N°›</a:t>
+              <a:t>‹#›</a:t>
             </a:fld>
             <a:endParaRPr lang="en-US"/>
           </a:p>
@@ -2220,9 +1872,10 @@
           <a:lstStyle/>
           <a:p>
             <a:r>
-              <a:rPr lang="en-US"/>
+              <a:rPr lang="en-US" smtClean="0"/>
               <a:t>Click to edit Master title style</a:t>
             </a:r>
+            <a:endParaRPr lang="en-US"/>
           </a:p>
         </p:txBody>
       </p:sp>
@@ -2243,7 +1896,7 @@
           <a:p>
             <a:fld id="{5BCAD085-E8A6-8845-BD4E-CB4CCA059FC4}" type="datetimeFigureOut">
               <a:rPr lang="en-US" smtClean="0"/>
-              <a:t>5/16/2026</a:t>
+              <a:t>1/27/13</a:t>
             </a:fld>
             <a:endParaRPr lang="en-US"/>
           </a:p>
@@ -2285,7 +1938,7 @@
           <a:p>
             <a:fld id="{C1FF6DA9-008F-8B48-92A6-B652298478BF}" type="slidenum">
               <a:rPr lang="en-US" smtClean="0"/>
-              <a:t>‹N°›</a:t>
+              <a:t>‹#›</a:t>
             </a:fld>
             <a:endParaRPr lang="en-US"/>
           </a:p>
@@ -2338,7 +1991,7 @@
           <a:p>
             <a:fld id="{5BCAD085-E8A6-8845-BD4E-CB4CCA059FC4}" type="datetimeFigureOut">
               <a:rPr lang="en-US" smtClean="0"/>
-              <a:t>5/16/2026</a:t>
+              <a:t>1/27/13</a:t>
             </a:fld>
             <a:endParaRPr lang="en-US"/>
           </a:p>
@@ -2380,7 +2033,7 @@
           <a:p>
             <a:fld id="{C1FF6DA9-008F-8B48-92A6-B652298478BF}" type="slidenum">
               <a:rPr lang="en-US" smtClean="0"/>
-              <a:t>‹N°›</a:t>
+              <a:t>‹#›</a:t>
             </a:fld>
             <a:endParaRPr lang="en-US"/>
           </a:p>
@@ -2441,9 +2094,10 @@
           </a:lstStyle>
           <a:p>
             <a:r>
-              <a:rPr lang="en-US"/>
+              <a:rPr lang="en-US" smtClean="0"/>
               <a:t>Click to edit Master title style</a:t>
             </a:r>
+            <a:endParaRPr lang="en-US"/>
           </a:p>
         </p:txBody>
       </p:sp>
@@ -2497,37 +2151,38 @@
           <a:p>
             <a:pPr lvl="0"/>
             <a:r>
-              <a:rPr lang="en-US"/>
+              <a:rPr lang="en-US" smtClean="0"/>
               <a:t>Click to edit Master text styles</a:t>
             </a:r>
           </a:p>
           <a:p>
             <a:pPr lvl="1"/>
             <a:r>
-              <a:rPr lang="en-US"/>
+              <a:rPr lang="en-US" smtClean="0"/>
               <a:t>Second level</a:t>
             </a:r>
           </a:p>
           <a:p>
             <a:pPr lvl="2"/>
             <a:r>
-              <a:rPr lang="en-US"/>
+              <a:rPr lang="en-US" smtClean="0"/>
               <a:t>Third level</a:t>
             </a:r>
           </a:p>
           <a:p>
             <a:pPr lvl="3"/>
             <a:r>
-              <a:rPr lang="en-US"/>
+              <a:rPr lang="en-US" smtClean="0"/>
               <a:t>Fourth level</a:t>
             </a:r>
           </a:p>
           <a:p>
             <a:pPr lvl="4"/>
             <a:r>
-              <a:rPr lang="en-US"/>
+              <a:rPr lang="en-US" smtClean="0"/>
               <a:t>Fifth level</a:t>
             </a:r>
+            <a:endParaRPr lang="en-US"/>
           </a:p>
         </p:txBody>
       </p:sp>
@@ -2590,7 +2245,7 @@
           <a:p>
             <a:pPr lvl="0"/>
             <a:r>
-              <a:rPr lang="en-US"/>
+              <a:rPr lang="en-US" smtClean="0"/>
               <a:t>Click to edit Master text styles</a:t>
             </a:r>
           </a:p>
@@ -2613,7 +2268,7 @@
           <a:p>
             <a:fld id="{5BCAD085-E8A6-8845-BD4E-CB4CCA059FC4}" type="datetimeFigureOut">
               <a:rPr lang="en-US" smtClean="0"/>
-              <a:t>5/16/2026</a:t>
+              <a:t>1/27/13</a:t>
             </a:fld>
             <a:endParaRPr lang="en-US"/>
           </a:p>
@@ -2655,7 +2310,7 @@
           <a:p>
             <a:fld id="{C1FF6DA9-008F-8B48-92A6-B652298478BF}" type="slidenum">
               <a:rPr lang="en-US" smtClean="0"/>
-              <a:t>‹N°›</a:t>
+              <a:t>‹#›</a:t>
             </a:fld>
             <a:endParaRPr lang="en-US"/>
           </a:p>
@@ -2716,9 +2371,10 @@
           </a:lstStyle>
           <a:p>
             <a:r>
-              <a:rPr lang="en-US"/>
+              <a:rPr lang="en-US" smtClean="0"/>
               <a:t>Click to edit Master title style</a:t>
             </a:r>
+            <a:endParaRPr lang="en-US"/>
           </a:p>
         </p:txBody>
       </p:sp>
@@ -2842,7 +2498,7 @@
           <a:p>
             <a:pPr lvl="0"/>
             <a:r>
-              <a:rPr lang="en-US"/>
+              <a:rPr lang="en-US" smtClean="0"/>
               <a:t>Click to edit Master text styles</a:t>
             </a:r>
           </a:p>
@@ -2865,7 +2521,7 @@
           <a:p>
             <a:fld id="{5BCAD085-E8A6-8845-BD4E-CB4CCA059FC4}" type="datetimeFigureOut">
               <a:rPr lang="en-US" smtClean="0"/>
-              <a:t>5/16/2026</a:t>
+              <a:t>1/27/13</a:t>
             </a:fld>
             <a:endParaRPr lang="en-US"/>
           </a:p>
@@ -2907,7 +2563,7 @@
           <a:p>
             <a:fld id="{C1FF6DA9-008F-8B48-92A6-B652298478BF}" type="slidenum">
               <a:rPr lang="en-US" smtClean="0"/>
-              <a:t>‹N°›</a:t>
+              <a:t>‹#›</a:t>
             </a:fld>
             <a:endParaRPr lang="en-US"/>
           </a:p>
@@ -2974,9 +2630,10 @@
           <a:lstStyle/>
           <a:p>
             <a:r>
-              <a:rPr lang="en-US"/>
+              <a:rPr lang="en-US" smtClean="0"/>
               <a:t>Click to edit Master title style</a:t>
             </a:r>
+            <a:endParaRPr lang="en-US"/>
           </a:p>
         </p:txBody>
       </p:sp>
@@ -3007,37 +2664,38 @@
           <a:p>
             <a:pPr lvl="0"/>
             <a:r>
-              <a:rPr lang="en-US"/>
+              <a:rPr lang="en-US" smtClean="0"/>
               <a:t>Click to edit Master text styles</a:t>
             </a:r>
           </a:p>
           <a:p>
             <a:pPr lvl="1"/>
             <a:r>
-              <a:rPr lang="en-US"/>
+              <a:rPr lang="en-US" smtClean="0"/>
               <a:t>Second level</a:t>
             </a:r>
           </a:p>
           <a:p>
             <a:pPr lvl="2"/>
             <a:r>
-              <a:rPr lang="en-US"/>
+              <a:rPr lang="en-US" smtClean="0"/>
               <a:t>Third level</a:t>
             </a:r>
           </a:p>
           <a:p>
             <a:pPr lvl="3"/>
             <a:r>
-              <a:rPr lang="en-US"/>
+              <a:rPr lang="en-US" smtClean="0"/>
               <a:t>Fourth level</a:t>
             </a:r>
           </a:p>
           <a:p>
             <a:pPr lvl="4"/>
             <a:r>
-              <a:rPr lang="en-US"/>
+              <a:rPr lang="en-US" smtClean="0"/>
               <a:t>Fifth level</a:t>
             </a:r>
+            <a:endParaRPr lang="en-US"/>
           </a:p>
         </p:txBody>
       </p:sp>
@@ -3076,7 +2734,7 @@
           <a:p>
             <a:fld id="{5BCAD085-E8A6-8845-BD4E-CB4CCA059FC4}" type="datetimeFigureOut">
               <a:rPr lang="en-US" smtClean="0"/>
-              <a:t>5/16/2026</a:t>
+              <a:t>1/27/13</a:t>
             </a:fld>
             <a:endParaRPr lang="en-US"/>
           </a:p>
@@ -3154,7 +2812,7 @@
           <a:p>
             <a:fld id="{C1FF6DA9-008F-8B48-92A6-B652298478BF}" type="slidenum">
               <a:rPr lang="en-US" smtClean="0"/>
-              <a:t>‹N°›</a:t>
+              <a:t>‹#›</a:t>
             </a:fld>
             <a:endParaRPr lang="en-US"/>
           </a:p>
@@ -3437,6 +3095,14 @@
 <file path=ppt/slides/slide1.xml><?xml version="1.0" encoding="utf-8"?>
 <p:sld xmlns:a="http://schemas.openxmlformats.org/drawingml/2006/main" xmlns:p="http://schemas.openxmlformats.org/presentationml/2006/main" xmlns:r="http://schemas.openxmlformats.org/officeDocument/2006/relationships">
   <p:cSld>
+    <p:bg>
+      <p:bgPr>
+        <a:solidFill>
+          <a:srgbClr val="1A5C33"/>
+        </a:solidFill>
+        <a:effectLst/>
+      </p:bgPr>
+    </p:bg>
     <p:spTree>
       <p:nvGrpSpPr>
         <p:cNvPr id="1" name=""/>
@@ -3446,56 +3112,14 @@
       <p:grpSpPr/>
       <p:sp>
         <p:nvSpPr>
-          <p:cNvPr id="2" name="Title 1"/>
-          <p:cNvSpPr>
-            <a:spLocks noGrp="1"/>
-          </p:cNvSpPr>
-          <p:nvPr>
-            <p:ph type="ctrTitle"/>
-          </p:nvPr>
-        </p:nvSpPr>
-        <p:spPr/>
-        <p:txBody>
-          <a:bodyPr/>
-          <a:lstStyle/>
-          <a:p>
-            <a:r>
-              <a:t>Introduction aux TIC</a:t>
-            </a:r>
-          </a:p>
-        </p:txBody>
-      </p:sp>
-      <p:sp>
-        <p:nvSpPr>
-          <p:cNvPr id="3" name="Subtitle 2"/>
-          <p:cNvSpPr>
-            <a:spLocks noGrp="1"/>
-          </p:cNvSpPr>
-          <p:nvPr>
-            <p:ph type="subTitle" idx="1"/>
-          </p:nvPr>
-        </p:nvSpPr>
-        <p:spPr/>
-        <p:txBody>
-          <a:bodyPr/>
-          <a:lstStyle/>
-          <a:p>
-            <a:r>
-              <a:t>Cours TIC 01 | 1h30 (90 min) | BELACEL Madani</a:t>
-            </a:r>
-          </a:p>
-        </p:txBody>
-      </p:sp>
-      <p:sp>
-        <p:nvSpPr>
-          <p:cNvPr id="4" name="TextBox 3"/>
+          <p:cNvPr id="2" name="TextBox 1"/>
           <p:cNvSpPr txBox="1"/>
           <p:nvPr/>
         </p:nvSpPr>
         <p:spPr>
           <a:xfrm>
-            <a:off x="365760" y="6446520"/>
-            <a:ext cx="8412480" cy="320040"/>
+            <a:off x="731520" y="1371600"/>
+            <a:ext cx="7680960" cy="1371600"/>
           </a:xfrm>
           <a:prstGeom prst="rect">
             <a:avLst/>
@@ -3503,20 +3127,90 @@
           <a:noFill/>
         </p:spPr>
         <p:txBody>
-          <a:bodyPr wrap="none">
+          <a:bodyPr wrap="square">
             <a:spAutoFit/>
           </a:bodyPr>
           <a:lstStyle/>
           <a:p>
             <a:pPr algn="ctr">
-              <a:defRPr sz="900">
-                <a:solidFill>
-                  <a:srgbClr val="404040"/>
-                </a:solidFill>
-              </a:defRPr>
-            </a:pPr>
-            <a:r>
-              <a:t>Cours TIC 01  •  Diapositive 1/10</a:t>
+              <a:defRPr sz="3200" b="1">
+                <a:solidFill>
+                  <a:srgbClr val="FFFFFF"/>
+                </a:solidFill>
+              </a:defRPr>
+            </a:pPr>
+            <a:r>
+              <a:t>ICT Course 01 — Introduction to ICT (ENS)</a:t>
+            </a:r>
+          </a:p>
+        </p:txBody>
+      </p:sp>
+      <p:sp>
+        <p:nvSpPr>
+          <p:cNvPr id="3" name="TextBox 2"/>
+          <p:cNvSpPr txBox="1"/>
+          <p:nvPr/>
+        </p:nvSpPr>
+        <p:spPr>
+          <a:xfrm>
+            <a:off x="731520" y="2926080"/>
+            <a:ext cx="7680960" cy="548640"/>
+          </a:xfrm>
+          <a:prstGeom prst="rect">
+            <a:avLst/>
+          </a:prstGeom>
+          <a:noFill/>
+        </p:spPr>
+        <p:txBody>
+          <a:bodyPr wrap="square">
+            <a:spAutoFit/>
+          </a:bodyPr>
+          <a:lstStyle/>
+          <a:p>
+            <a:pPr algn="ctr">
+              <a:defRPr sz="2000" b="0">
+                <a:solidFill>
+                  <a:srgbClr val="C5D9C7"/>
+                </a:solidFill>
+              </a:defRPr>
+            </a:pPr>
+            <a:r>
+              <a:t>Module TIC — Dr. BELACEL Madani</a:t>
+            </a:r>
+          </a:p>
+        </p:txBody>
+      </p:sp>
+      <p:sp>
+        <p:nvSpPr>
+          <p:cNvPr id="4" name="TextBox 3"/>
+          <p:cNvSpPr txBox="1"/>
+          <p:nvPr/>
+        </p:nvSpPr>
+        <p:spPr>
+          <a:xfrm>
+            <a:off x="731520" y="3657600"/>
+            <a:ext cx="7680960" cy="457200"/>
+          </a:xfrm>
+          <a:prstGeom prst="rect">
+            <a:avLst/>
+          </a:prstGeom>
+          <a:noFill/>
+        </p:spPr>
+        <p:txBody>
+          <a:bodyPr wrap="square">
+            <a:spAutoFit/>
+          </a:bodyPr>
+          <a:lstStyle/>
+          <a:p>
+            <a:pPr algn="ctr">
+              <a:defRPr sz="1600" b="0">
+                <a:solidFill>
+                  <a:srgbClr val="A0CFA0"/>
+                </a:solidFill>
+              </a:defRPr>
+            </a:pPr>
+            <a:r>
+              <a:t>Université de Mostaganem — MCB</a:t>
             </a:r>
           </a:p>
         </p:txBody>
@@ -3526,15 +3220,20 @@
   <p:clrMapOvr>
     <a:masterClrMapping/>
   </p:clrMapOvr>
-  <p:transition spd="med">
-    <p:fade/>
-  </p:transition>
 </p:sld>
 </file>
 
 <file path=ppt/slides/slide10.xml><?xml version="1.0" encoding="utf-8"?>
 <p:sld xmlns:a="http://schemas.openxmlformats.org/drawingml/2006/main" xmlns:p="http://schemas.openxmlformats.org/presentationml/2006/main" xmlns:r="http://schemas.openxmlformats.org/officeDocument/2006/relationships">
   <p:cSld>
+    <p:bg>
+      <p:bgPr>
+        <a:solidFill>
+          <a:srgbClr val="FFFFFF"/>
+        </a:solidFill>
+        <a:effectLst/>
+      </p:bgPr>
+    </p:bg>
     <p:spTree>
       <p:nvGrpSpPr>
         <p:cNvPr id="1" name=""/>
@@ -3544,83 +3243,57 @@
       <p:grpSpPr/>
       <p:sp>
         <p:nvSpPr>
-          <p:cNvPr id="2" name="Title 1"/>
-          <p:cNvSpPr>
-            <a:spLocks noGrp="1"/>
-          </p:cNvSpPr>
-          <p:nvPr>
-            <p:ph type="title"/>
-          </p:nvPr>
-        </p:nvSpPr>
-        <p:spPr/>
-        <p:txBody>
-          <a:bodyPr/>
-          <a:lstStyle/>
-          <a:p>
-            <a:r>
-              <a:t>Conclusion</a:t>
-            </a:r>
-          </a:p>
-        </p:txBody>
-      </p:sp>
-      <p:sp>
-        <p:nvSpPr>
-          <p:cNvPr id="3" name="Content Placeholder 2"/>
-          <p:cNvSpPr>
-            <a:spLocks noGrp="1"/>
-          </p:cNvSpPr>
-          <p:nvPr>
-            <p:ph idx="1"/>
-          </p:nvPr>
-        </p:nvSpPr>
-        <p:spPr/>
-        <p:txBody>
-          <a:bodyPr/>
-          <a:lstStyle/>
-          <a:p>
-            <a:pPr>
-              <a:defRPr sz="2000"/>
-            </a:pPr>
-            <a:r>
-              <a:t>✅ Compétence transversale</a:t>
-            </a:r>
-          </a:p>
-          <a:p>
-            <a:pPr>
-              <a:defRPr sz="2000"/>
-            </a:pPr>
-            <a:r>
-              <a:t>✅ TD 01 — 1h30</a:t>
-            </a:r>
-          </a:p>
-          <a:p>
-            <a:pPr>
-              <a:defRPr sz="2000"/>
-            </a:pPr>
-            <a:r>
-              <a:t>✅ Prochain : Ordinateur</a:t>
-            </a:r>
-          </a:p>
-          <a:p>
-            <a:pPr>
-              <a:defRPr sz="2000"/>
-            </a:pPr>
-            <a:r>
-              <a:t>✅ Questions ?</a:t>
-            </a:r>
-          </a:p>
-        </p:txBody>
-      </p:sp>
-      <p:sp>
-        <p:nvSpPr>
-          <p:cNvPr id="4" name="TextBox 3"/>
+          <p:cNvPr id="2" name="Rectangle 1"/>
+          <p:cNvSpPr/>
+          <p:nvPr/>
+        </p:nvSpPr>
+        <p:spPr>
+          <a:xfrm>
+            <a:off x="0" y="0"/>
+            <a:ext cx="109728" cy="6858000"/>
+          </a:xfrm>
+          <a:prstGeom prst="rect">
+            <a:avLst/>
+          </a:prstGeom>
+          <a:solidFill>
+            <a:srgbClr val="2C6E49"/>
+          </a:solidFill>
+          <a:ln>
+            <a:noFill/>
+          </a:ln>
+        </p:spPr>
+        <p:style>
+          <a:lnRef idx="1">
+            <a:schemeClr val="accent1"/>
+          </a:lnRef>
+          <a:fillRef idx="3">
+            <a:schemeClr val="accent1"/>
+          </a:fillRef>
+          <a:effectRef idx="2">
+            <a:schemeClr val="accent1"/>
+          </a:effectRef>
+          <a:fontRef idx="minor">
+            <a:schemeClr val="lt1"/>
+          </a:fontRef>
+        </p:style>
+        <p:txBody>
+          <a:bodyPr rtlCol="0" anchor="ctr"/>
+          <a:lstStyle/>
+          <a:p>
+            <a:pPr algn="ctr"/>
+          </a:p>
+        </p:txBody>
+      </p:sp>
+      <p:sp>
+        <p:nvSpPr>
+          <p:cNvPr id="3" name="TextBox 2"/>
           <p:cNvSpPr txBox="1"/>
           <p:nvPr/>
         </p:nvSpPr>
         <p:spPr>
           <a:xfrm>
-            <a:off x="365760" y="6446520"/>
-            <a:ext cx="8412480" cy="320040"/>
+            <a:off x="548640" y="2286000"/>
+            <a:ext cx="7772400" cy="914400"/>
           </a:xfrm>
           <a:prstGeom prst="rect">
             <a:avLst/>
@@ -3628,20 +3301,108 @@
           <a:noFill/>
         </p:spPr>
         <p:txBody>
-          <a:bodyPr wrap="none">
+          <a:bodyPr wrap="square">
             <a:spAutoFit/>
           </a:bodyPr>
           <a:lstStyle/>
           <a:p>
             <a:pPr algn="ctr">
-              <a:defRPr sz="900">
-                <a:solidFill>
-                  <a:srgbClr val="404040"/>
-                </a:solidFill>
-              </a:defRPr>
-            </a:pPr>
-            <a:r>
-              <a:t>Cours TIC 01  •  Diapositive 10/10</a:t>
+              <a:defRPr sz="2600" b="1">
+                <a:solidFill>
+                  <a:srgbClr val="1A5C33"/>
+                </a:solidFill>
+              </a:defRPr>
+            </a:pPr>
+            <a:r>
+              <a:t>📝 Points clés à retenir</a:t>
+            </a:r>
+          </a:p>
+        </p:txBody>
+      </p:sp>
+      <p:sp>
+        <p:nvSpPr>
+          <p:cNvPr id="4" name="TextBox 3"/>
+          <p:cNvSpPr txBox="1"/>
+          <p:nvPr/>
+        </p:nvSpPr>
+        <p:spPr>
+          <a:xfrm>
+            <a:off x="548640" y="1828800"/>
+            <a:ext cx="7772400" cy="4572000"/>
+          </a:xfrm>
+          <a:prstGeom prst="rect">
+            <a:avLst/>
+          </a:prstGeom>
+          <a:noFill/>
+        </p:spPr>
+        <p:txBody>
+          <a:bodyPr wrap="square">
+            <a:spAutoFit/>
+          </a:bodyPr>
+          <a:lstStyle/>
+          <a:p>
+            <a:pPr>
+              <a:spcAft>
+                <a:spcPts val="600"/>
+              </a:spcAft>
+              <a:defRPr sz="1600">
+                <a:solidFill>
+                  <a:srgbClr val="222222"/>
+                </a:solidFill>
+              </a:defRPr>
+            </a:pPr>
+            <a:r>
+              <a:t>• Knowledge:- Define ICT and its evolution</a:t>
+            </a:r>
+            <a:br/>
+            <a:r>
+              <a:t>- Distinguish technical, information, and communication dimensions</a:t>
+            </a:r>
+            <a:br/>
+            <a:r>
+              <a:t>- Understand pedagogical ICT integration in language didactics</a:t>
+            </a:r>
+          </a:p>
+          <a:p>
+            <a:pPr>
+              <a:spcAft>
+                <a:spcPts val="600"/>
+              </a:spcAft>
+              <a:defRPr sz="1600">
+                <a:solidFill>
+                  <a:srgbClr val="222222"/>
+                </a:solidFill>
+              </a:defRPr>
+            </a:pPr>
+            <a:r>
+              <a:t>• ICTcovers digital tools and systems for creating, processing, storing, transmitting, and sharing information.</a:t>
+            </a:r>
+          </a:p>
+          <a:p>
+            <a:pPr>
+              <a:spcAft>
+                <a:spcPts val="600"/>
+              </a:spcAft>
+              <a:defRPr sz="1600">
+                <a:solidFill>
+                  <a:srgbClr val="222222"/>
+                </a:solidFill>
+              </a:defRPr>
+            </a:pPr>
+            <a:r>
+              <a:t>• Why integrate ICT in language teaching?- Learner motivation and engagement</a:t>
+            </a:r>
+            <a:br/>
+            <a:r>
+              <a:t>- Access to authentic resources (videos, articles, podcasts)</a:t>
+            </a:r>
+            <a:br/>
+            <a:r>
+              <a:t>- Individualized learning paths</a:t>
+            </a:r>
+            <a:br/>
+            <a:r>
+              <a:t>- Autonomy development</a:t>
             </a:r>
           </a:p>
         </p:txBody>
@@ -3651,15 +3412,20 @@
   <p:clrMapOvr>
     <a:masterClrMapping/>
   </p:clrMapOvr>
-  <p:transition spd="med">
-    <p:fade/>
-  </p:transition>
 </p:sld>
 </file>
 
-<file path=ppt/slides/slide2.xml><?xml version="1.0" encoding="utf-8"?>
+<file path=ppt/slides/slide11.xml><?xml version="1.0" encoding="utf-8"?>
 <p:sld xmlns:a="http://schemas.openxmlformats.org/drawingml/2006/main" xmlns:p="http://schemas.openxmlformats.org/presentationml/2006/main" xmlns:r="http://schemas.openxmlformats.org/officeDocument/2006/relationships">
   <p:cSld>
+    <p:bg>
+      <p:bgPr>
+        <a:solidFill>
+          <a:srgbClr val="FFFFFF"/>
+        </a:solidFill>
+        <a:effectLst/>
+      </p:bgPr>
+    </p:bg>
     <p:spTree>
       <p:nvGrpSpPr>
         <p:cNvPr id="1" name=""/>
@@ -3669,83 +3435,57 @@
       <p:grpSpPr/>
       <p:sp>
         <p:nvSpPr>
-          <p:cNvPr id="2" name="Title 1"/>
-          <p:cNvSpPr>
-            <a:spLocks noGrp="1"/>
-          </p:cNvSpPr>
-          <p:nvPr>
-            <p:ph type="title"/>
-          </p:nvPr>
-        </p:nvSpPr>
-        <p:spPr/>
-        <p:txBody>
-          <a:bodyPr/>
-          <a:lstStyle/>
-          <a:p>
-            <a:r>
-              <a:t>Objectifs pédagogiques</a:t>
-            </a:r>
-          </a:p>
-        </p:txBody>
-      </p:sp>
-      <p:sp>
-        <p:nvSpPr>
-          <p:cNvPr id="3" name="Content Placeholder 2"/>
-          <p:cNvSpPr>
-            <a:spLocks noGrp="1"/>
-          </p:cNvSpPr>
-          <p:nvPr>
-            <p:ph idx="1"/>
-          </p:nvPr>
-        </p:nvSpPr>
-        <p:spPr/>
-        <p:txBody>
-          <a:bodyPr/>
-          <a:lstStyle/>
-          <a:p>
-            <a:pPr>
-              <a:defRPr sz="2000"/>
-            </a:pPr>
-            <a:r>
-              <a:t>🎯 Définir les TIC et leurs 3 dimensions</a:t>
-            </a:r>
-          </a:p>
-          <a:p>
-            <a:pPr>
-              <a:defRPr sz="2000"/>
-            </a:pPr>
-            <a:r>
-              <a:t>🎯 Comprendre traitement / transmission / sauvegarde</a:t>
-            </a:r>
-          </a:p>
-          <a:p>
-            <a:pPr>
-              <a:defRPr sz="2000"/>
-            </a:pPr>
-            <a:r>
-              <a:t>🎯 Identifier services et applications</a:t>
-            </a:r>
-          </a:p>
-          <a:p>
-            <a:pPr>
-              <a:defRPr sz="2000"/>
-            </a:pPr>
-            <a:r>
-              <a:t>🎯 Compétences numériques en langues</a:t>
-            </a:r>
-          </a:p>
-        </p:txBody>
-      </p:sp>
-      <p:sp>
-        <p:nvSpPr>
-          <p:cNvPr id="4" name="TextBox 3"/>
+          <p:cNvPr id="2" name="Rectangle 1"/>
+          <p:cNvSpPr/>
+          <p:nvPr/>
+        </p:nvSpPr>
+        <p:spPr>
+          <a:xfrm>
+            <a:off x="0" y="0"/>
+            <a:ext cx="109728" cy="6858000"/>
+          </a:xfrm>
+          <a:prstGeom prst="rect">
+            <a:avLst/>
+          </a:prstGeom>
+          <a:solidFill>
+            <a:srgbClr val="2C6E49"/>
+          </a:solidFill>
+          <a:ln>
+            <a:noFill/>
+          </a:ln>
+        </p:spPr>
+        <p:style>
+          <a:lnRef idx="1">
+            <a:schemeClr val="accent1"/>
+          </a:lnRef>
+          <a:fillRef idx="3">
+            <a:schemeClr val="accent1"/>
+          </a:fillRef>
+          <a:effectRef idx="2">
+            <a:schemeClr val="accent1"/>
+          </a:effectRef>
+          <a:fontRef idx="minor">
+            <a:schemeClr val="lt1"/>
+          </a:fontRef>
+        </p:style>
+        <p:txBody>
+          <a:bodyPr rtlCol="0" anchor="ctr"/>
+          <a:lstStyle/>
+          <a:p>
+            <a:pPr algn="ctr"/>
+          </a:p>
+        </p:txBody>
+      </p:sp>
+      <p:sp>
+        <p:nvSpPr>
+          <p:cNvPr id="3" name="TextBox 2"/>
           <p:cNvSpPr txBox="1"/>
           <p:nvPr/>
         </p:nvSpPr>
         <p:spPr>
           <a:xfrm>
-            <a:off x="365760" y="6446520"/>
-            <a:ext cx="8412480" cy="320040"/>
+            <a:off x="548640" y="2286000"/>
+            <a:ext cx="7772400" cy="914400"/>
           </a:xfrm>
           <a:prstGeom prst="rect">
             <a:avLst/>
@@ -3753,20 +3493,108 @@
           <a:noFill/>
         </p:spPr>
         <p:txBody>
-          <a:bodyPr wrap="none">
+          <a:bodyPr wrap="square">
             <a:spAutoFit/>
           </a:bodyPr>
           <a:lstStyle/>
           <a:p>
             <a:pPr algn="ctr">
-              <a:defRPr sz="900">
-                <a:solidFill>
-                  <a:srgbClr val="404040"/>
-                </a:solidFill>
-              </a:defRPr>
-            </a:pPr>
-            <a:r>
-              <a:t>Cours TIC 01  •  Diapositive 2/10</a:t>
+              <a:defRPr sz="2600" b="1">
+                <a:solidFill>
+                  <a:srgbClr val="1A5C33"/>
+                </a:solidFill>
+              </a:defRPr>
+            </a:pPr>
+            <a:r>
+              <a:t>📝 Points clés à retenir</a:t>
+            </a:r>
+          </a:p>
+        </p:txBody>
+      </p:sp>
+      <p:sp>
+        <p:nvSpPr>
+          <p:cNvPr id="4" name="TextBox 3"/>
+          <p:cNvSpPr txBox="1"/>
+          <p:nvPr/>
+        </p:nvSpPr>
+        <p:spPr>
+          <a:xfrm>
+            <a:off x="548640" y="1828800"/>
+            <a:ext cx="7772400" cy="4572000"/>
+          </a:xfrm>
+          <a:prstGeom prst="rect">
+            <a:avLst/>
+          </a:prstGeom>
+          <a:noFill/>
+        </p:spPr>
+        <p:txBody>
+          <a:bodyPr wrap="square">
+            <a:spAutoFit/>
+          </a:bodyPr>
+          <a:lstStyle/>
+          <a:p>
+            <a:pPr>
+              <a:spcAft>
+                <a:spcPts val="600"/>
+              </a:spcAft>
+              <a:defRPr sz="1600">
+                <a:solidFill>
+                  <a:srgbClr val="222222"/>
+                </a:solidFill>
+              </a:defRPr>
+            </a:pPr>
+            <a:r>
+              <a:t>• Knowledge:- Define ICT and its evolution</a:t>
+            </a:r>
+            <a:br/>
+            <a:r>
+              <a:t>- Distinguish technical, information, and communication dimensions</a:t>
+            </a:r>
+            <a:br/>
+            <a:r>
+              <a:t>- Understand pedagogical ICT integration in language didactics</a:t>
+            </a:r>
+          </a:p>
+          <a:p>
+            <a:pPr>
+              <a:spcAft>
+                <a:spcPts val="600"/>
+              </a:spcAft>
+              <a:defRPr sz="1600">
+                <a:solidFill>
+                  <a:srgbClr val="222222"/>
+                </a:solidFill>
+              </a:defRPr>
+            </a:pPr>
+            <a:r>
+              <a:t>• ICTcovers digital tools and systems for creating, processing, storing, transmitting, and sharing information.</a:t>
+            </a:r>
+          </a:p>
+          <a:p>
+            <a:pPr>
+              <a:spcAft>
+                <a:spcPts val="600"/>
+              </a:spcAft>
+              <a:defRPr sz="1600">
+                <a:solidFill>
+                  <a:srgbClr val="222222"/>
+                </a:solidFill>
+              </a:defRPr>
+            </a:pPr>
+            <a:r>
+              <a:t>• Why integrate ICT in language teaching?- Learner motivation and engagement</a:t>
+            </a:r>
+            <a:br/>
+            <a:r>
+              <a:t>- Access to authentic resources (videos, articles, podcasts)</a:t>
+            </a:r>
+            <a:br/>
+            <a:r>
+              <a:t>- Individualized learning paths</a:t>
+            </a:r>
+            <a:br/>
+            <a:r>
+              <a:t>- Autonomy development</a:t>
             </a:r>
           </a:p>
         </p:txBody>
@@ -3776,15 +3604,20 @@
   <p:clrMapOvr>
     <a:masterClrMapping/>
   </p:clrMapOvr>
-  <p:transition spd="med">
-    <p:fade/>
-  </p:transition>
 </p:sld>
 </file>
 
-<file path=ppt/slides/slide3.xml><?xml version="1.0" encoding="utf-8"?>
+<file path=ppt/slides/slide12.xml><?xml version="1.0" encoding="utf-8"?>
 <p:sld xmlns:a="http://schemas.openxmlformats.org/drawingml/2006/main" xmlns:p="http://schemas.openxmlformats.org/presentationml/2006/main" xmlns:r="http://schemas.openxmlformats.org/officeDocument/2006/relationships">
   <p:cSld>
+    <p:bg>
+      <p:bgPr>
+        <a:solidFill>
+          <a:srgbClr val="FFFFFF"/>
+        </a:solidFill>
+        <a:effectLst/>
+      </p:bgPr>
+    </p:bg>
     <p:spTree>
       <p:nvGrpSpPr>
         <p:cNvPr id="1" name=""/>
@@ -3794,83 +3627,57 @@
       <p:grpSpPr/>
       <p:sp>
         <p:nvSpPr>
-          <p:cNvPr id="2" name="Title 1"/>
-          <p:cNvSpPr>
-            <a:spLocks noGrp="1"/>
-          </p:cNvSpPr>
-          <p:nvPr>
-            <p:ph type="title"/>
-          </p:nvPr>
-        </p:nvSpPr>
-        <p:spPr/>
-        <p:txBody>
-          <a:bodyPr/>
-          <a:lstStyle/>
-          <a:p>
-            <a:r>
-              <a:t>Plan du cours (1h30)</a:t>
-            </a:r>
-          </a:p>
-        </p:txBody>
-      </p:sp>
-      <p:sp>
-        <p:nvSpPr>
-          <p:cNvPr id="3" name="Content Placeholder 2"/>
-          <p:cNvSpPr>
-            <a:spLocks noGrp="1"/>
-          </p:cNvSpPr>
-          <p:nvPr>
-            <p:ph idx="1"/>
-          </p:nvPr>
-        </p:nvSpPr>
-        <p:spPr/>
-        <p:txBody>
-          <a:bodyPr/>
-          <a:lstStyle/>
-          <a:p>
-            <a:pPr>
-              <a:defRPr sz="2000"/>
-            </a:pPr>
-            <a:r>
-              <a:t>📋 9 parties — 90 minutes</a:t>
-            </a:r>
-          </a:p>
-          <a:p>
-            <a:pPr>
-              <a:defRPr sz="2000"/>
-            </a:pPr>
-            <a:r>
-              <a:t>📋 Intro → Définition → NTIC</a:t>
-            </a:r>
-          </a:p>
-          <a:p>
-            <a:pPr>
-              <a:defRPr sz="2000"/>
-            </a:pPr>
-            <a:r>
-              <a:t>📋 Dimensions → Fonctions → Services</a:t>
-            </a:r>
-          </a:p>
-          <a:p>
-            <a:pPr>
-              <a:defRPr sz="2000"/>
-            </a:pPr>
-            <a:r>
-              <a:t>📋 Éducation → Compétences → Conclusion</a:t>
-            </a:r>
-          </a:p>
-        </p:txBody>
-      </p:sp>
-      <p:sp>
-        <p:nvSpPr>
-          <p:cNvPr id="4" name="TextBox 3"/>
+          <p:cNvPr id="2" name="Rectangle 1"/>
+          <p:cNvSpPr/>
+          <p:nvPr/>
+        </p:nvSpPr>
+        <p:spPr>
+          <a:xfrm>
+            <a:off x="0" y="0"/>
+            <a:ext cx="109728" cy="6858000"/>
+          </a:xfrm>
+          <a:prstGeom prst="rect">
+            <a:avLst/>
+          </a:prstGeom>
+          <a:solidFill>
+            <a:srgbClr val="2C6E49"/>
+          </a:solidFill>
+          <a:ln>
+            <a:noFill/>
+          </a:ln>
+        </p:spPr>
+        <p:style>
+          <a:lnRef idx="1">
+            <a:schemeClr val="accent1"/>
+          </a:lnRef>
+          <a:fillRef idx="3">
+            <a:schemeClr val="accent1"/>
+          </a:fillRef>
+          <a:effectRef idx="2">
+            <a:schemeClr val="accent1"/>
+          </a:effectRef>
+          <a:fontRef idx="minor">
+            <a:schemeClr val="lt1"/>
+          </a:fontRef>
+        </p:style>
+        <p:txBody>
+          <a:bodyPr rtlCol="0" anchor="ctr"/>
+          <a:lstStyle/>
+          <a:p>
+            <a:pPr algn="ctr"/>
+          </a:p>
+        </p:txBody>
+      </p:sp>
+      <p:sp>
+        <p:nvSpPr>
+          <p:cNvPr id="3" name="TextBox 2"/>
           <p:cNvSpPr txBox="1"/>
           <p:nvPr/>
         </p:nvSpPr>
         <p:spPr>
           <a:xfrm>
-            <a:off x="365760" y="6446520"/>
-            <a:ext cx="8412480" cy="320040"/>
+            <a:off x="548640" y="2286000"/>
+            <a:ext cx="7772400" cy="914400"/>
           </a:xfrm>
           <a:prstGeom prst="rect">
             <a:avLst/>
@@ -3878,20 +3685,108 @@
           <a:noFill/>
         </p:spPr>
         <p:txBody>
-          <a:bodyPr wrap="none">
+          <a:bodyPr wrap="square">
             <a:spAutoFit/>
           </a:bodyPr>
           <a:lstStyle/>
           <a:p>
             <a:pPr algn="ctr">
-              <a:defRPr sz="900">
-                <a:solidFill>
-                  <a:srgbClr val="404040"/>
-                </a:solidFill>
-              </a:defRPr>
-            </a:pPr>
-            <a:r>
-              <a:t>Cours TIC 01  •  Diapositive 3/10</a:t>
+              <a:defRPr sz="2600" b="1">
+                <a:solidFill>
+                  <a:srgbClr val="1A5C33"/>
+                </a:solidFill>
+              </a:defRPr>
+            </a:pPr>
+            <a:r>
+              <a:t>📝 Points clés à retenir</a:t>
+            </a:r>
+          </a:p>
+        </p:txBody>
+      </p:sp>
+      <p:sp>
+        <p:nvSpPr>
+          <p:cNvPr id="4" name="TextBox 3"/>
+          <p:cNvSpPr txBox="1"/>
+          <p:nvPr/>
+        </p:nvSpPr>
+        <p:spPr>
+          <a:xfrm>
+            <a:off x="548640" y="1828800"/>
+            <a:ext cx="7772400" cy="4572000"/>
+          </a:xfrm>
+          <a:prstGeom prst="rect">
+            <a:avLst/>
+          </a:prstGeom>
+          <a:noFill/>
+        </p:spPr>
+        <p:txBody>
+          <a:bodyPr wrap="square">
+            <a:spAutoFit/>
+          </a:bodyPr>
+          <a:lstStyle/>
+          <a:p>
+            <a:pPr>
+              <a:spcAft>
+                <a:spcPts val="600"/>
+              </a:spcAft>
+              <a:defRPr sz="1600">
+                <a:solidFill>
+                  <a:srgbClr val="222222"/>
+                </a:solidFill>
+              </a:defRPr>
+            </a:pPr>
+            <a:r>
+              <a:t>• Knowledge:- Define ICT and its evolution</a:t>
+            </a:r>
+            <a:br/>
+            <a:r>
+              <a:t>- Distinguish technical, information, and communication dimensions</a:t>
+            </a:r>
+            <a:br/>
+            <a:r>
+              <a:t>- Understand pedagogical ICT integration in language didactics</a:t>
+            </a:r>
+          </a:p>
+          <a:p>
+            <a:pPr>
+              <a:spcAft>
+                <a:spcPts val="600"/>
+              </a:spcAft>
+              <a:defRPr sz="1600">
+                <a:solidFill>
+                  <a:srgbClr val="222222"/>
+                </a:solidFill>
+              </a:defRPr>
+            </a:pPr>
+            <a:r>
+              <a:t>• ICTcovers digital tools and systems for creating, processing, storing, transmitting, and sharing information.</a:t>
+            </a:r>
+          </a:p>
+          <a:p>
+            <a:pPr>
+              <a:spcAft>
+                <a:spcPts val="600"/>
+              </a:spcAft>
+              <a:defRPr sz="1600">
+                <a:solidFill>
+                  <a:srgbClr val="222222"/>
+                </a:solidFill>
+              </a:defRPr>
+            </a:pPr>
+            <a:r>
+              <a:t>• Why integrate ICT in language teaching?- Learner motivation and engagement</a:t>
+            </a:r>
+            <a:br/>
+            <a:r>
+              <a:t>- Access to authentic resources (videos, articles, podcasts)</a:t>
+            </a:r>
+            <a:br/>
+            <a:r>
+              <a:t>- Individualized learning paths</a:t>
+            </a:r>
+            <a:br/>
+            <a:r>
+              <a:t>- Autonomy development</a:t>
             </a:r>
           </a:p>
         </p:txBody>
@@ -3901,15 +3796,20 @@
   <p:clrMapOvr>
     <a:masterClrMapping/>
   </p:clrMapOvr>
-  <p:transition spd="med">
-    <p:fade/>
-  </p:transition>
 </p:sld>
 </file>
 
-<file path=ppt/slides/slide4.xml><?xml version="1.0" encoding="utf-8"?>
+<file path=ppt/slides/slide13.xml><?xml version="1.0" encoding="utf-8"?>
 <p:sld xmlns:a="http://schemas.openxmlformats.org/drawingml/2006/main" xmlns:p="http://schemas.openxmlformats.org/presentationml/2006/main" xmlns:r="http://schemas.openxmlformats.org/officeDocument/2006/relationships">
   <p:cSld>
+    <p:bg>
+      <p:bgPr>
+        <a:solidFill>
+          <a:srgbClr val="E8F0E9"/>
+        </a:solidFill>
+        <a:effectLst/>
+      </p:bgPr>
+    </p:bg>
     <p:spTree>
       <p:nvGrpSpPr>
         <p:cNvPr id="1" name=""/>
@@ -3919,83 +3819,14 @@
       <p:grpSpPr/>
       <p:sp>
         <p:nvSpPr>
-          <p:cNvPr id="2" name="Title 1"/>
-          <p:cNvSpPr>
-            <a:spLocks noGrp="1"/>
-          </p:cNvSpPr>
-          <p:nvPr>
-            <p:ph type="title"/>
-          </p:nvPr>
-        </p:nvSpPr>
-        <p:spPr/>
-        <p:txBody>
-          <a:bodyPr/>
-          <a:lstStyle/>
-          <a:p>
-            <a:r>
-              <a:t>Définition des TIC</a:t>
-            </a:r>
-          </a:p>
-        </p:txBody>
-      </p:sp>
-      <p:sp>
-        <p:nvSpPr>
-          <p:cNvPr id="3" name="Content Placeholder 2"/>
-          <p:cNvSpPr>
-            <a:spLocks noGrp="1"/>
-          </p:cNvSpPr>
-          <p:nvPr>
-            <p:ph idx="1"/>
-          </p:nvPr>
-        </p:nvSpPr>
-        <p:spPr/>
-        <p:txBody>
-          <a:bodyPr/>
-          <a:lstStyle/>
-          <a:p>
-            <a:pPr>
-              <a:defRPr sz="2000"/>
-            </a:pPr>
-            <a:r>
-              <a:t>💡 Convergence numérique</a:t>
-            </a:r>
-          </a:p>
-          <a:p>
-            <a:pPr>
-              <a:defRPr sz="2000"/>
-            </a:pPr>
-            <a:r>
-              <a:t>💡 Créer, stocker, transmettre</a:t>
-            </a:r>
-          </a:p>
-          <a:p>
-            <a:pPr>
-              <a:defRPr sz="2000"/>
-            </a:pPr>
-            <a:r>
-              <a:t>💡 Définition UIT / UNESCO</a:t>
-            </a:r>
-          </a:p>
-          <a:p>
-            <a:pPr>
-              <a:defRPr sz="2000"/>
-            </a:pPr>
-            <a:r>
-              <a:t>💡 ICT en anglais</a:t>
-            </a:r>
-          </a:p>
-        </p:txBody>
-      </p:sp>
-      <p:sp>
-        <p:nvSpPr>
-          <p:cNvPr id="4" name="TextBox 3"/>
+          <p:cNvPr id="2" name="TextBox 1"/>
           <p:cNvSpPr txBox="1"/>
           <p:nvPr/>
         </p:nvSpPr>
         <p:spPr>
           <a:xfrm>
-            <a:off x="365760" y="6446520"/>
-            <a:ext cx="8412480" cy="320040"/>
+            <a:off x="548640" y="365760"/>
+            <a:ext cx="7772400" cy="640080"/>
           </a:xfrm>
           <a:prstGeom prst="rect">
             <a:avLst/>
@@ -4003,20 +3834,138 @@
           <a:noFill/>
         </p:spPr>
         <p:txBody>
-          <a:bodyPr wrap="none">
+          <a:bodyPr wrap="square">
             <a:spAutoFit/>
           </a:bodyPr>
           <a:lstStyle/>
           <a:p>
             <a:pPr algn="ctr">
-              <a:defRPr sz="900">
-                <a:solidFill>
-                  <a:srgbClr val="404040"/>
-                </a:solidFill>
-              </a:defRPr>
-            </a:pPr>
-            <a:r>
-              <a:t>Cours TIC 01  •  Diapositive 4/10</a:t>
+              <a:defRPr sz="2600" b="1">
+                <a:solidFill>
+                  <a:srgbClr val="1A5C33"/>
+                </a:solidFill>
+              </a:defRPr>
+            </a:pPr>
+            <a:r>
+              <a:t>📝 Points clés à retenir</a:t>
+            </a:r>
+          </a:p>
+        </p:txBody>
+      </p:sp>
+      <p:sp>
+        <p:nvSpPr>
+          <p:cNvPr id="3" name="TextBox 2"/>
+          <p:cNvSpPr txBox="1"/>
+          <p:nvPr/>
+        </p:nvSpPr>
+        <p:spPr>
+          <a:xfrm>
+            <a:off x="548640" y="1828800"/>
+            <a:ext cx="7772400" cy="4572000"/>
+          </a:xfrm>
+          <a:prstGeom prst="rect">
+            <a:avLst/>
+          </a:prstGeom>
+          <a:noFill/>
+        </p:spPr>
+        <p:txBody>
+          <a:bodyPr wrap="square">
+            <a:spAutoFit/>
+          </a:bodyPr>
+          <a:lstStyle/>
+          <a:p>
+            <a:pPr>
+              <a:spcAft>
+                <a:spcPts val="600"/>
+              </a:spcAft>
+              <a:defRPr sz="1600">
+                <a:solidFill>
+                  <a:srgbClr val="222222"/>
+                </a:solidFill>
+              </a:defRPr>
+            </a:pPr>
+            <a:r>
+              <a:t>• Knowledge:- Define ICT and its evolution</a:t>
+            </a:r>
+            <a:br/>
+            <a:r>
+              <a:t>- Distinguish technical, information, and communication dimensions</a:t>
+            </a:r>
+            <a:br/>
+            <a:r>
+              <a:t>- Understand pedagogical ICT integration in language didactics</a:t>
+            </a:r>
+          </a:p>
+          <a:p>
+            <a:pPr>
+              <a:spcAft>
+                <a:spcPts val="600"/>
+              </a:spcAft>
+              <a:defRPr sz="1600">
+                <a:solidFill>
+                  <a:srgbClr val="222222"/>
+                </a:solidFill>
+              </a:defRPr>
+            </a:pPr>
+            <a:r>
+              <a:t>• ICTcovers digital tools and systems for creating, processing, storing, transmitting, and sharing information.</a:t>
+            </a:r>
+          </a:p>
+          <a:p>
+            <a:pPr>
+              <a:spcAft>
+                <a:spcPts val="600"/>
+              </a:spcAft>
+              <a:defRPr sz="1600">
+                <a:solidFill>
+                  <a:srgbClr val="222222"/>
+                </a:solidFill>
+              </a:defRPr>
+            </a:pPr>
+            <a:r>
+              <a:t>• Why integrate ICT in language teaching?- Learner motivation and engagement</a:t>
+            </a:r>
+            <a:br/>
+            <a:r>
+              <a:t>- Access to authentic resources (videos, articles, podcasts)</a:t>
+            </a:r>
+            <a:br/>
+            <a:r>
+              <a:t>- Individualized learning paths</a:t>
+            </a:r>
+            <a:br/>
+            <a:r>
+              <a:t>- Autonomy development</a:t>
+            </a:r>
+          </a:p>
+          <a:p>
+            <a:pPr>
+              <a:spcAft>
+                <a:spcPts val="600"/>
+              </a:spcAft>
+              <a:defRPr sz="1600">
+                <a:solidFill>
+                  <a:srgbClr val="222222"/>
+                </a:solidFill>
+              </a:defRPr>
+            </a:pPr>
+            <a:r>
+              <a:t>• Design sequences integrating digital tools</a:t>
+            </a:r>
+          </a:p>
+          <a:p>
+            <a:pPr>
+              <a:spcAft>
+                <a:spcPts val="600"/>
+              </a:spcAft>
+              <a:defRPr sz="1600">
+                <a:solidFill>
+                  <a:srgbClr val="222222"/>
+                </a:solidFill>
+              </a:defRPr>
+            </a:pPr>
+            <a:r>
+              <a:t>• GDPR compliance:protect student data</a:t>
             </a:r>
           </a:p>
         </p:txBody>
@@ -4026,15 +3975,20 @@
   <p:clrMapOvr>
     <a:masterClrMapping/>
   </p:clrMapOvr>
-  <p:transition spd="med">
-    <p:fade/>
-  </p:transition>
 </p:sld>
 </file>
 
-<file path=ppt/slides/slide5.xml><?xml version="1.0" encoding="utf-8"?>
+<file path=ppt/slides/slide14.xml><?xml version="1.0" encoding="utf-8"?>
 <p:sld xmlns:a="http://schemas.openxmlformats.org/drawingml/2006/main" xmlns:p="http://schemas.openxmlformats.org/presentationml/2006/main" xmlns:r="http://schemas.openxmlformats.org/officeDocument/2006/relationships">
   <p:cSld>
+    <p:bg>
+      <p:bgPr>
+        <a:solidFill>
+          <a:srgbClr val="FFFFFF"/>
+        </a:solidFill>
+        <a:effectLst/>
+      </p:bgPr>
+    </p:bg>
     <p:spTree>
       <p:nvGrpSpPr>
         <p:cNvPr id="1" name=""/>
@@ -4044,83 +3998,14 @@
       <p:grpSpPr/>
       <p:sp>
         <p:nvSpPr>
-          <p:cNvPr id="2" name="Title 1"/>
-          <p:cNvSpPr>
-            <a:spLocks noGrp="1"/>
-          </p:cNvSpPr>
-          <p:nvPr>
-            <p:ph type="title"/>
-          </p:nvPr>
-        </p:nvSpPr>
-        <p:spPr/>
-        <p:txBody>
-          <a:bodyPr/>
-          <a:lstStyle/>
-          <a:p>
-            <a:r>
-              <a:t>NTIC → TIC</a:t>
-            </a:r>
-          </a:p>
-        </p:txBody>
-      </p:sp>
-      <p:sp>
-        <p:nvSpPr>
-          <p:cNvPr id="3" name="Content Placeholder 2"/>
-          <p:cNvSpPr>
-            <a:spLocks noGrp="1"/>
-          </p:cNvSpPr>
-          <p:nvPr>
-            <p:ph idx="1"/>
-          </p:nvPr>
-        </p:nvSpPr>
-        <p:spPr/>
-        <p:txBody>
-          <a:bodyPr/>
-          <a:lstStyle/>
-          <a:p>
-            <a:pPr>
-              <a:defRPr sz="2000"/>
-            </a:pPr>
-            <a:r>
-              <a:t>📖 1990-2005 : NTIC</a:t>
-            </a:r>
-          </a:p>
-          <a:p>
-            <a:pPr>
-              <a:defRPr sz="2000"/>
-            </a:pPr>
-            <a:r>
-              <a:t>📖 Aujourd'hui : TIC</a:t>
-            </a:r>
-          </a:p>
-          <a:p>
-            <a:pPr>
-              <a:defRPr sz="2000"/>
-            </a:pPr>
-            <a:r>
-              <a:t>📖 Transformation digitale</a:t>
-            </a:r>
-          </a:p>
-          <a:p>
-            <a:pPr>
-              <a:defRPr sz="2000"/>
-            </a:pPr>
-            <a:r>
-              <a:t>📖 Société de l'information</a:t>
-            </a:r>
-          </a:p>
-        </p:txBody>
-      </p:sp>
-      <p:sp>
-        <p:nvSpPr>
-          <p:cNvPr id="4" name="TextBox 3"/>
+          <p:cNvPr id="2" name="TextBox 1"/>
           <p:cNvSpPr txBox="1"/>
           <p:nvPr/>
         </p:nvSpPr>
         <p:spPr>
           <a:xfrm>
-            <a:off x="365760" y="6446520"/>
-            <a:ext cx="8412480" cy="320040"/>
+            <a:off x="548640" y="365760"/>
+            <a:ext cx="7772400" cy="640080"/>
           </a:xfrm>
           <a:prstGeom prst="rect">
             <a:avLst/>
@@ -4128,20 +4013,118 @@
           <a:noFill/>
         </p:spPr>
         <p:txBody>
-          <a:bodyPr wrap="none">
+          <a:bodyPr wrap="square">
             <a:spAutoFit/>
           </a:bodyPr>
           <a:lstStyle/>
           <a:p>
             <a:pPr algn="ctr">
-              <a:defRPr sz="900">
-                <a:solidFill>
-                  <a:srgbClr val="404040"/>
-                </a:solidFill>
-              </a:defRPr>
-            </a:pPr>
-            <a:r>
-              <a:t>Cours TIC 01  •  Diapositive 5/10</a:t>
+              <a:defRPr sz="2600" b="1">
+                <a:solidFill>
+                  <a:srgbClr val="1A5C33"/>
+                </a:solidFill>
+              </a:defRPr>
+            </a:pPr>
+            <a:r>
+              <a:t>✏️ Exercices d'application</a:t>
+            </a:r>
+          </a:p>
+        </p:txBody>
+      </p:sp>
+      <p:sp>
+        <p:nvSpPr>
+          <p:cNvPr id="3" name="TextBox 2"/>
+          <p:cNvSpPr txBox="1"/>
+          <p:nvPr/>
+        </p:nvSpPr>
+        <p:spPr>
+          <a:xfrm>
+            <a:off x="548640" y="1828800"/>
+            <a:ext cx="7772400" cy="4572000"/>
+          </a:xfrm>
+          <a:prstGeom prst="rect">
+            <a:avLst/>
+          </a:prstGeom>
+          <a:noFill/>
+        </p:spPr>
+        <p:txBody>
+          <a:bodyPr wrap="square">
+            <a:spAutoFit/>
+          </a:bodyPr>
+          <a:lstStyle/>
+          <a:p>
+            <a:pPr>
+              <a:spcAft>
+                <a:spcPts val="600"/>
+              </a:spcAft>
+              <a:defRPr sz="1500">
+                <a:solidFill>
+                  <a:srgbClr val="222222"/>
+                </a:solidFill>
+              </a:defRPr>
+            </a:pPr>
+            <a:r>
+              <a:t>• Définir les concepts principaux du cours</a:t>
+            </a:r>
+          </a:p>
+          <a:p>
+            <a:pPr>
+              <a:spcAft>
+                <a:spcPts val="600"/>
+              </a:spcAft>
+              <a:defRPr sz="1500">
+                <a:solidFill>
+                  <a:srgbClr val="222222"/>
+                </a:solidFill>
+              </a:defRPr>
+            </a:pPr>
+            <a:r>
+              <a:t>• Identifier les applications pratiques</a:t>
+            </a:r>
+          </a:p>
+          <a:p>
+            <a:pPr>
+              <a:spcAft>
+                <a:spcPts val="600"/>
+              </a:spcAft>
+              <a:defRPr sz="1500">
+                <a:solidFill>
+                  <a:srgbClr val="222222"/>
+                </a:solidFill>
+              </a:defRPr>
+            </a:pPr>
+            <a:r>
+              <a:t>• Résoudre les exercices du TD</a:t>
+            </a:r>
+          </a:p>
+          <a:p>
+            <a:pPr>
+              <a:spcAft>
+                <a:spcPts val="600"/>
+              </a:spcAft>
+              <a:defRPr sz="1500">
+                <a:solidFill>
+                  <a:srgbClr val="222222"/>
+                </a:solidFill>
+              </a:defRPr>
+            </a:pPr>
+            <a:r>
+              <a:t>• Synthétiser les points clés en un paragraphe</a:t>
+            </a:r>
+          </a:p>
+          <a:p>
+            <a:pPr>
+              <a:spcAft>
+                <a:spcPts val="600"/>
+              </a:spcAft>
+              <a:defRPr sz="1500">
+                <a:solidFill>
+                  <a:srgbClr val="222222"/>
+                </a:solidFill>
+              </a:defRPr>
+            </a:pPr>
+            <a:r>
+              <a:t>• Préparer une courte présentation orale</a:t>
             </a:r>
           </a:p>
         </p:txBody>
@@ -4151,15 +4134,20 @@
   <p:clrMapOvr>
     <a:masterClrMapping/>
   </p:clrMapOvr>
-  <p:transition spd="med">
-    <p:fade/>
-  </p:transition>
 </p:sld>
 </file>
 
-<file path=ppt/slides/slide6.xml><?xml version="1.0" encoding="utf-8"?>
+<file path=ppt/slides/slide15.xml><?xml version="1.0" encoding="utf-8"?>
 <p:sld xmlns:a="http://schemas.openxmlformats.org/drawingml/2006/main" xmlns:p="http://schemas.openxmlformats.org/presentationml/2006/main" xmlns:r="http://schemas.openxmlformats.org/officeDocument/2006/relationships">
   <p:cSld>
+    <p:bg>
+      <p:bgPr>
+        <a:solidFill>
+          <a:srgbClr val="1A5C33"/>
+        </a:solidFill>
+        <a:effectLst/>
+      </p:bgPr>
+    </p:bg>
     <p:spTree>
       <p:nvGrpSpPr>
         <p:cNvPr id="1" name=""/>
@@ -4169,83 +4157,14 @@
       <p:grpSpPr/>
       <p:sp>
         <p:nvSpPr>
-          <p:cNvPr id="2" name="Title 1"/>
-          <p:cNvSpPr>
-            <a:spLocks noGrp="1"/>
-          </p:cNvSpPr>
-          <p:nvPr>
-            <p:ph type="title"/>
-          </p:nvPr>
-        </p:nvSpPr>
-        <p:spPr/>
-        <p:txBody>
-          <a:bodyPr/>
-          <a:lstStyle/>
-          <a:p>
-            <a:r>
-              <a:t>Trois dimensions</a:t>
-            </a:r>
-          </a:p>
-        </p:txBody>
-      </p:sp>
-      <p:sp>
-        <p:nvSpPr>
-          <p:cNvPr id="3" name="Content Placeholder 2"/>
-          <p:cNvSpPr>
-            <a:spLocks noGrp="1"/>
-          </p:cNvSpPr>
-          <p:nvPr>
-            <p:ph idx="1"/>
-          </p:nvPr>
-        </p:nvSpPr>
-        <p:spPr/>
-        <p:txBody>
-          <a:bodyPr/>
-          <a:lstStyle/>
-          <a:p>
-            <a:pPr>
-              <a:defRPr sz="2000"/>
-            </a:pPr>
-            <a:r>
-              <a:t>🔺 Techniques (outils)</a:t>
-            </a:r>
-          </a:p>
-          <a:p>
-            <a:pPr>
-              <a:defRPr sz="2000"/>
-            </a:pPr>
-            <a:r>
-              <a:t>🔺 Information (données)</a:t>
-            </a:r>
-          </a:p>
-          <a:p>
-            <a:pPr>
-              <a:defRPr sz="2000"/>
-            </a:pPr>
-            <a:r>
-              <a:t>🔺 Communication (échange)</a:t>
-            </a:r>
-          </a:p>
-          <a:p>
-            <a:pPr>
-              <a:defRPr sz="2000"/>
-            </a:pPr>
-            <a:r>
-              <a:t>🔺 Schéma triangulaire</a:t>
-            </a:r>
-          </a:p>
-        </p:txBody>
-      </p:sp>
-      <p:sp>
-        <p:nvSpPr>
-          <p:cNvPr id="4" name="TextBox 3"/>
+          <p:cNvPr id="2" name="TextBox 1"/>
           <p:cNvSpPr txBox="1"/>
           <p:nvPr/>
         </p:nvSpPr>
         <p:spPr>
           <a:xfrm>
-            <a:off x="365760" y="6446520"/>
-            <a:ext cx="8412480" cy="320040"/>
+            <a:off x="731520" y="1371600"/>
+            <a:ext cx="7680960" cy="914400"/>
           </a:xfrm>
           <a:prstGeom prst="rect">
             <a:avLst/>
@@ -4253,20 +4172,67 @@
           <a:noFill/>
         </p:spPr>
         <p:txBody>
-          <a:bodyPr wrap="none">
+          <a:bodyPr wrap="square">
             <a:spAutoFit/>
           </a:bodyPr>
           <a:lstStyle/>
           <a:p>
             <a:pPr algn="ctr">
-              <a:defRPr sz="900">
-                <a:solidFill>
-                  <a:srgbClr val="404040"/>
-                </a:solidFill>
-              </a:defRPr>
-            </a:pPr>
-            <a:r>
-              <a:t>Cours TIC 01  •  Diapositive 6/10</a:t>
+              <a:defRPr sz="2800" b="1">
+                <a:solidFill>
+                  <a:srgbClr val="FFFFFF"/>
+                </a:solidFill>
+              </a:defRPr>
+            </a:pPr>
+            <a:r>
+              <a:t>🎓 Conclusion</a:t>
+            </a:r>
+          </a:p>
+        </p:txBody>
+      </p:sp>
+      <p:sp>
+        <p:nvSpPr>
+          <p:cNvPr id="3" name="TextBox 2"/>
+          <p:cNvSpPr txBox="1"/>
+          <p:nvPr/>
+        </p:nvSpPr>
+        <p:spPr>
+          <a:xfrm>
+            <a:off x="731520" y="2743200"/>
+            <a:ext cx="7680960" cy="1828800"/>
+          </a:xfrm>
+          <a:prstGeom prst="rect">
+            <a:avLst/>
+          </a:prstGeom>
+          <a:noFill/>
+        </p:spPr>
+        <p:txBody>
+          <a:bodyPr wrap="square">
+            <a:spAutoFit/>
+          </a:bodyPr>
+          <a:lstStyle/>
+          <a:p>
+            <a:pPr algn="ctr">
+              <a:defRPr sz="1800" b="0">
+                <a:solidFill>
+                  <a:srgbClr val="C5D9C7"/>
+                </a:solidFill>
+              </a:defRPr>
+            </a:pPr>
+            <a:r>
+              <a:t>Dr. BELACEL Madani</a:t>
+            </a:r>
+            <a:br/>
+            <a:r>
+              <a:t>Maître de Conférences B</a:t>
+            </a:r>
+            <a:br/>
+            <a:r>
+              <a:t>Université de Mostaganem</a:t>
+            </a:r>
+            <a:br/>
+            <a:r>
+              <a:t>madani.belacel@univ-mosta.dz</a:t>
             </a:r>
           </a:p>
         </p:txBody>
@@ -4276,15 +4242,20 @@
   <p:clrMapOvr>
     <a:masterClrMapping/>
   </p:clrMapOvr>
-  <p:transition spd="med">
-    <p:fade/>
-  </p:transition>
 </p:sld>
 </file>
 
-<file path=ppt/slides/slide7.xml><?xml version="1.0" encoding="utf-8"?>
+<file path=ppt/slides/slide2.xml><?xml version="1.0" encoding="utf-8"?>
 <p:sld xmlns:a="http://schemas.openxmlformats.org/drawingml/2006/main" xmlns:p="http://schemas.openxmlformats.org/presentationml/2006/main" xmlns:r="http://schemas.openxmlformats.org/officeDocument/2006/relationships">
   <p:cSld>
+    <p:bg>
+      <p:bgPr>
+        <a:solidFill>
+          <a:srgbClr val="FFFFFF"/>
+        </a:solidFill>
+        <a:effectLst/>
+      </p:bgPr>
+    </p:bg>
     <p:spTree>
       <p:nvGrpSpPr>
         <p:cNvPr id="1" name=""/>
@@ -4294,83 +4265,14 @@
       <p:grpSpPr/>
       <p:sp>
         <p:nvSpPr>
-          <p:cNvPr id="2" name="Title 1"/>
-          <p:cNvSpPr>
-            <a:spLocks noGrp="1"/>
-          </p:cNvSpPr>
-          <p:nvPr>
-            <p:ph type="title"/>
-          </p:nvPr>
-        </p:nvSpPr>
-        <p:spPr/>
-        <p:txBody>
-          <a:bodyPr/>
-          <a:lstStyle/>
-          <a:p>
-            <a:r>
-              <a:t>Trois fonctions</a:t>
-            </a:r>
-          </a:p>
-        </p:txBody>
-      </p:sp>
-      <p:sp>
-        <p:nvSpPr>
-          <p:cNvPr id="3" name="Content Placeholder 2"/>
-          <p:cNvSpPr>
-            <a:spLocks noGrp="1"/>
-          </p:cNvSpPr>
-          <p:nvPr>
-            <p:ph idx="1"/>
-          </p:nvPr>
-        </p:nvSpPr>
-        <p:spPr/>
-        <p:txBody>
-          <a:bodyPr/>
-          <a:lstStyle/>
-          <a:p>
-            <a:pPr>
-              <a:defRPr sz="2000"/>
-            </a:pPr>
-            <a:r>
-              <a:t>⚙️ Traitement (Word)</a:t>
-            </a:r>
-          </a:p>
-          <a:p>
-            <a:pPr>
-              <a:defRPr sz="2000"/>
-            </a:pPr>
-            <a:r>
-              <a:t>⚙️ Transmission (email)</a:t>
-            </a:r>
-          </a:p>
-          <a:p>
-            <a:pPr>
-              <a:defRPr sz="2000"/>
-            </a:pPr>
-            <a:r>
-              <a:t>⚙️ Sauvegarde (cloud)</a:t>
-            </a:r>
-          </a:p>
-          <a:p>
-            <a:pPr>
-              <a:defRPr sz="2000"/>
-            </a:pPr>
-            <a:r>
-              <a:t>⚙️ Exemple étudiant</a:t>
-            </a:r>
-          </a:p>
-        </p:txBody>
-      </p:sp>
-      <p:sp>
-        <p:nvSpPr>
-          <p:cNvPr id="4" name="TextBox 3"/>
+          <p:cNvPr id="2" name="TextBox 1"/>
           <p:cNvSpPr txBox="1"/>
           <p:nvPr/>
         </p:nvSpPr>
         <p:spPr>
           <a:xfrm>
-            <a:off x="365760" y="6446520"/>
-            <a:ext cx="8412480" cy="320040"/>
+            <a:off x="548640" y="365760"/>
+            <a:ext cx="7772400" cy="640080"/>
           </a:xfrm>
           <a:prstGeom prst="rect">
             <a:avLst/>
@@ -4378,20 +4280,88 @@
           <a:noFill/>
         </p:spPr>
         <p:txBody>
-          <a:bodyPr wrap="none">
+          <a:bodyPr wrap="square">
             <a:spAutoFit/>
           </a:bodyPr>
           <a:lstStyle/>
           <a:p>
-            <a:pPr algn="ctr">
-              <a:defRPr sz="900">
-                <a:solidFill>
-                  <a:srgbClr val="404040"/>
-                </a:solidFill>
-              </a:defRPr>
-            </a:pPr>
-            <a:r>
-              <a:t>Cours TIC 01  •  Diapositive 7/10</a:t>
+            <a:pPr algn="l">
+              <a:defRPr sz="2600" b="1">
+                <a:solidFill>
+                  <a:srgbClr val="1A5C33"/>
+                </a:solidFill>
+              </a:defRPr>
+            </a:pPr>
+            <a:r>
+              <a:t>🎯 Objectifs pédagogiques</a:t>
+            </a:r>
+          </a:p>
+        </p:txBody>
+      </p:sp>
+      <p:sp>
+        <p:nvSpPr>
+          <p:cNvPr id="3" name="TextBox 2"/>
+          <p:cNvSpPr txBox="1"/>
+          <p:nvPr/>
+        </p:nvSpPr>
+        <p:spPr>
+          <a:xfrm>
+            <a:off x="548640" y="1828800"/>
+            <a:ext cx="7772400" cy="4572000"/>
+          </a:xfrm>
+          <a:prstGeom prst="rect">
+            <a:avLst/>
+          </a:prstGeom>
+          <a:noFill/>
+        </p:spPr>
+        <p:txBody>
+          <a:bodyPr wrap="square">
+            <a:spAutoFit/>
+          </a:bodyPr>
+          <a:lstStyle/>
+          <a:p>
+            <a:pPr>
+              <a:spcAft>
+                <a:spcPts val="600"/>
+              </a:spcAft>
+              <a:defRPr sz="1500">
+                <a:solidFill>
+                  <a:srgbClr val="222222"/>
+                </a:solidFill>
+              </a:defRPr>
+            </a:pPr>
+            <a:r>
+              <a:t>• Comprendre les concepts clés</a:t>
+            </a:r>
+          </a:p>
+          <a:p>
+            <a:pPr>
+              <a:spcAft>
+                <a:spcPts val="600"/>
+              </a:spcAft>
+              <a:defRPr sz="1500">
+                <a:solidFill>
+                  <a:srgbClr val="222222"/>
+                </a:solidFill>
+              </a:defRPr>
+            </a:pPr>
+            <a:r>
+              <a:t>• Appliquer les compétences</a:t>
+            </a:r>
+          </a:p>
+          <a:p>
+            <a:pPr>
+              <a:spcAft>
+                <a:spcPts val="600"/>
+              </a:spcAft>
+              <a:defRPr sz="1500">
+                <a:solidFill>
+                  <a:srgbClr val="222222"/>
+                </a:solidFill>
+              </a:defRPr>
+            </a:pPr>
+            <a:r>
+              <a:t>• Évaluer les technologies</a:t>
             </a:r>
           </a:p>
         </p:txBody>
@@ -4401,15 +4371,20 @@
   <p:clrMapOvr>
     <a:masterClrMapping/>
   </p:clrMapOvr>
-  <p:transition spd="med">
-    <p:fade/>
-  </p:transition>
 </p:sld>
 </file>
 
-<file path=ppt/slides/slide8.xml><?xml version="1.0" encoding="utf-8"?>
+<file path=ppt/slides/slide3.xml><?xml version="1.0" encoding="utf-8"?>
 <p:sld xmlns:a="http://schemas.openxmlformats.org/drawingml/2006/main" xmlns:p="http://schemas.openxmlformats.org/presentationml/2006/main" xmlns:r="http://schemas.openxmlformats.org/officeDocument/2006/relationships">
   <p:cSld>
+    <p:bg>
+      <p:bgPr>
+        <a:solidFill>
+          <a:srgbClr val="FFFFFF"/>
+        </a:solidFill>
+        <a:effectLst/>
+      </p:bgPr>
+    </p:bg>
     <p:spTree>
       <p:nvGrpSpPr>
         <p:cNvPr id="1" name=""/>
@@ -4419,83 +4394,14 @@
       <p:grpSpPr/>
       <p:sp>
         <p:nvSpPr>
-          <p:cNvPr id="2" name="Title 1"/>
-          <p:cNvSpPr>
-            <a:spLocks noGrp="1"/>
-          </p:cNvSpPr>
-          <p:nvPr>
-            <p:ph type="title"/>
-          </p:nvPr>
-        </p:nvSpPr>
-        <p:spPr/>
-        <p:txBody>
-          <a:bodyPr/>
-          <a:lstStyle/>
-          <a:p>
-            <a:r>
-              <a:t>Services et éducation</a:t>
-            </a:r>
-          </a:p>
-        </p:txBody>
-      </p:sp>
-      <p:sp>
-        <p:nvSpPr>
-          <p:cNvPr id="3" name="Content Placeholder 2"/>
-          <p:cNvSpPr>
-            <a:spLocks noGrp="1"/>
-          </p:cNvSpPr>
-          <p:nvPr>
-            <p:ph idx="1"/>
-          </p:nvPr>
-        </p:nvSpPr>
-        <p:spPr/>
-        <p:txBody>
-          <a:bodyPr/>
-          <a:lstStyle/>
-          <a:p>
-            <a:pPr>
-              <a:defRPr sz="2000"/>
-            </a:pPr>
-            <a:r>
-              <a:t>🎓 Courriel, Web, visio</a:t>
-            </a:r>
-          </a:p>
-          <a:p>
-            <a:pPr>
-              <a:defRPr sz="2000"/>
-            </a:pPr>
-            <a:r>
-              <a:t>🎓 Moodle / Classroom</a:t>
-            </a:r>
-          </a:p>
-          <a:p>
-            <a:pPr>
-              <a:defRPr sz="2000"/>
-            </a:pPr>
-            <a:r>
-              <a:t>🎓 E-learning hybride</a:t>
-            </a:r>
-          </a:p>
-          <a:p>
-            <a:pPr>
-              <a:defRPr sz="2000"/>
-            </a:pPr>
-            <a:r>
-              <a:t>🎓 Ressources multilingues</a:t>
-            </a:r>
-          </a:p>
-        </p:txBody>
-      </p:sp>
-      <p:sp>
-        <p:nvSpPr>
-          <p:cNvPr id="4" name="TextBox 3"/>
+          <p:cNvPr id="2" name="TextBox 1"/>
           <p:cNvSpPr txBox="1"/>
           <p:nvPr/>
         </p:nvSpPr>
         <p:spPr>
           <a:xfrm>
-            <a:off x="365760" y="6446520"/>
-            <a:ext cx="8412480" cy="320040"/>
+            <a:off x="548640" y="365760"/>
+            <a:ext cx="7772400" cy="640080"/>
           </a:xfrm>
           <a:prstGeom prst="rect">
             <a:avLst/>
@@ -4503,20 +4409,133 @@
           <a:noFill/>
         </p:spPr>
         <p:txBody>
-          <a:bodyPr wrap="none">
+          <a:bodyPr wrap="square">
             <a:spAutoFit/>
           </a:bodyPr>
           <a:lstStyle/>
           <a:p>
-            <a:pPr algn="ctr">
-              <a:defRPr sz="900">
-                <a:solidFill>
-                  <a:srgbClr val="404040"/>
-                </a:solidFill>
-              </a:defRPr>
-            </a:pPr>
-            <a:r>
-              <a:t>Cours TIC 01  •  Diapositive 8/10</a:t>
+            <a:pPr algn="l">
+              <a:defRPr sz="2600" b="1">
+                <a:solidFill>
+                  <a:srgbClr val="1A5C33"/>
+                </a:solidFill>
+              </a:defRPr>
+            </a:pPr>
+            <a:r>
+              <a:t>📋 Plan du cours</a:t>
+            </a:r>
+          </a:p>
+        </p:txBody>
+      </p:sp>
+      <p:sp>
+        <p:nvSpPr>
+          <p:cNvPr id="3" name="TextBox 2"/>
+          <p:cNvSpPr txBox="1"/>
+          <p:nvPr/>
+        </p:nvSpPr>
+        <p:spPr>
+          <a:xfrm>
+            <a:off x="548640" y="1828800"/>
+            <a:ext cx="7772400" cy="4572000"/>
+          </a:xfrm>
+          <a:prstGeom prst="rect">
+            <a:avLst/>
+          </a:prstGeom>
+          <a:noFill/>
+        </p:spPr>
+        <p:txBody>
+          <a:bodyPr wrap="square">
+            <a:spAutoFit/>
+          </a:bodyPr>
+          <a:lstStyle/>
+          <a:p>
+            <a:pPr>
+              <a:spcAft>
+                <a:spcPts val="600"/>
+              </a:spcAft>
+              <a:defRPr sz="1600">
+                <a:solidFill>
+                  <a:srgbClr val="222222"/>
+                </a:solidFill>
+              </a:defRPr>
+            </a:pPr>
+            <a:r>
+              <a:t>• Learning Objectives</a:t>
+            </a:r>
+          </a:p>
+          <a:p>
+            <a:pPr>
+              <a:spcAft>
+                <a:spcPts val="600"/>
+              </a:spcAft>
+              <a:defRPr sz="1600">
+                <a:solidFill>
+                  <a:srgbClr val="222222"/>
+                </a:solidFill>
+              </a:defRPr>
+            </a:pPr>
+            <a:r>
+              <a:t>• 1. Definition and Evolution(10 min)</a:t>
+            </a:r>
+          </a:p>
+          <a:p>
+            <a:pPr>
+              <a:spcAft>
+                <a:spcPts val="600"/>
+              </a:spcAft>
+              <a:defRPr sz="1600">
+                <a:solidFill>
+                  <a:srgbClr val="222222"/>
+                </a:solidFill>
+              </a:defRPr>
+            </a:pPr>
+            <a:r>
+              <a:t>• 3. ICT and Pedagogy(20 min)</a:t>
+            </a:r>
+          </a:p>
+          <a:p>
+            <a:pPr>
+              <a:spcAft>
+                <a:spcPts val="600"/>
+              </a:spcAft>
+              <a:defRPr sz="1600">
+                <a:solidFill>
+                  <a:srgbClr val="222222"/>
+                </a:solidFill>
+              </a:defRPr>
+            </a:pPr>
+            <a:r>
+              <a:t>• 6. Teacher Digital Competencies(15 min)</a:t>
+            </a:r>
+          </a:p>
+          <a:p>
+            <a:pPr>
+              <a:spcAft>
+                <a:spcPts val="600"/>
+              </a:spcAft>
+              <a:defRPr sz="1600">
+                <a:solidFill>
+                  <a:srgbClr val="222222"/>
+                </a:solidFill>
+              </a:defRPr>
+            </a:pPr>
+            <a:r>
+              <a:t>• 7. Ethics and Security(10 min)</a:t>
+            </a:r>
+          </a:p>
+          <a:p>
+            <a:pPr>
+              <a:spcAft>
+                <a:spcPts val="600"/>
+              </a:spcAft>
+              <a:defRPr sz="1600">
+                <a:solidFill>
+                  <a:srgbClr val="222222"/>
+                </a:solidFill>
+              </a:defRPr>
+            </a:pPr>
+            <a:r>
+              <a:t>• 8. Conclusion(5 min)</a:t>
             </a:r>
           </a:p>
         </p:txBody>
@@ -4526,15 +4545,20 @@
   <p:clrMapOvr>
     <a:masterClrMapping/>
   </p:clrMapOvr>
-  <p:transition spd="med">
-    <p:fade/>
-  </p:transition>
 </p:sld>
 </file>
 
-<file path=ppt/slides/slide9.xml><?xml version="1.0" encoding="utf-8"?>
+<file path=ppt/slides/slide4.xml><?xml version="1.0" encoding="utf-8"?>
 <p:sld xmlns:a="http://schemas.openxmlformats.org/drawingml/2006/main" xmlns:p="http://schemas.openxmlformats.org/presentationml/2006/main" xmlns:r="http://schemas.openxmlformats.org/officeDocument/2006/relationships">
   <p:cSld>
+    <p:bg>
+      <p:bgPr>
+        <a:solidFill>
+          <a:srgbClr val="FFFFFF"/>
+        </a:solidFill>
+        <a:effectLst/>
+      </p:bgPr>
+    </p:bg>
     <p:spTree>
       <p:nvGrpSpPr>
         <p:cNvPr id="1" name=""/>
@@ -4544,83 +4568,57 @@
       <p:grpSpPr/>
       <p:sp>
         <p:nvSpPr>
-          <p:cNvPr id="2" name="Title 1"/>
-          <p:cNvSpPr>
-            <a:spLocks noGrp="1"/>
-          </p:cNvSpPr>
-          <p:nvPr>
-            <p:ph type="title"/>
-          </p:nvPr>
-        </p:nvSpPr>
-        <p:spPr/>
-        <p:txBody>
-          <a:bodyPr/>
-          <a:lstStyle/>
-          <a:p>
-            <a:r>
-              <a:t>Compétences attendues</a:t>
-            </a:r>
-          </a:p>
-        </p:txBody>
-      </p:sp>
-      <p:sp>
-        <p:nvSpPr>
-          <p:cNvPr id="3" name="Content Placeholder 2"/>
-          <p:cNvSpPr>
-            <a:spLocks noGrp="1"/>
-          </p:cNvSpPr>
-          <p:nvPr>
-            <p:ph idx="1"/>
-          </p:nvPr>
-        </p:nvSpPr>
-        <p:spPr/>
-        <p:txBody>
-          <a:bodyPr/>
-          <a:lstStyle/>
-          <a:p>
-            <a:pPr>
-              <a:defRPr sz="2000"/>
-            </a:pPr>
-            <a:r>
-              <a:t>✔️ Bureautique académique</a:t>
-            </a:r>
-          </a:p>
-          <a:p>
-            <a:pPr>
-              <a:defRPr sz="2000"/>
-            </a:pPr>
-            <a:r>
-              <a:t>✔️ Recherche documentaire</a:t>
-            </a:r>
-          </a:p>
-          <a:p>
-            <a:pPr>
-              <a:defRPr sz="2000"/>
-            </a:pPr>
-            <a:r>
-              <a:t>✔️ Fichiers et sauvegardes</a:t>
-            </a:r>
-          </a:p>
-          <a:p>
-            <a:pPr>
-              <a:defRPr sz="2000"/>
-            </a:pPr>
-            <a:r>
-              <a:t>✔️ Éthique numérique</a:t>
-            </a:r>
-          </a:p>
-        </p:txBody>
-      </p:sp>
-      <p:sp>
-        <p:nvSpPr>
-          <p:cNvPr id="4" name="TextBox 3"/>
+          <p:cNvPr id="2" name="Rectangle 1"/>
+          <p:cNvSpPr/>
+          <p:nvPr/>
+        </p:nvSpPr>
+        <p:spPr>
+          <a:xfrm>
+            <a:off x="0" y="0"/>
+            <a:ext cx="109728" cy="6858000"/>
+          </a:xfrm>
+          <a:prstGeom prst="rect">
+            <a:avLst/>
+          </a:prstGeom>
+          <a:solidFill>
+            <a:srgbClr val="2C6E49"/>
+          </a:solidFill>
+          <a:ln>
+            <a:noFill/>
+          </a:ln>
+        </p:spPr>
+        <p:style>
+          <a:lnRef idx="1">
+            <a:schemeClr val="accent1"/>
+          </a:lnRef>
+          <a:fillRef idx="3">
+            <a:schemeClr val="accent1"/>
+          </a:fillRef>
+          <a:effectRef idx="2">
+            <a:schemeClr val="accent1"/>
+          </a:effectRef>
+          <a:fontRef idx="minor">
+            <a:schemeClr val="lt1"/>
+          </a:fontRef>
+        </p:style>
+        <p:txBody>
+          <a:bodyPr rtlCol="0" anchor="ctr"/>
+          <a:lstStyle/>
+          <a:p>
+            <a:pPr algn="ctr"/>
+          </a:p>
+        </p:txBody>
+      </p:sp>
+      <p:sp>
+        <p:nvSpPr>
+          <p:cNvPr id="3" name="TextBox 2"/>
           <p:cNvSpPr txBox="1"/>
           <p:nvPr/>
         </p:nvSpPr>
         <p:spPr>
           <a:xfrm>
-            <a:off x="365760" y="6446520"/>
-            <a:ext cx="8412480" cy="320040"/>
+            <a:off x="457200" y="365760"/>
+            <a:ext cx="8229600" cy="640080"/>
           </a:xfrm>
           <a:prstGeom prst="rect">
             <a:avLst/>
@@ -4628,20 +4626,108 @@
           <a:noFill/>
         </p:spPr>
         <p:txBody>
-          <a:bodyPr wrap="none">
+          <a:bodyPr wrap="square">
             <a:spAutoFit/>
           </a:bodyPr>
           <a:lstStyle/>
           <a:p>
-            <a:pPr algn="ctr">
-              <a:defRPr sz="900">
-                <a:solidFill>
-                  <a:srgbClr val="404040"/>
-                </a:solidFill>
-              </a:defRPr>
-            </a:pPr>
-            <a:r>
-              <a:t>Cours TIC 01  •  Diapositive 9/10</a:t>
+            <a:pPr algn="l">
+              <a:defRPr sz="2200" b="1">
+                <a:solidFill>
+                  <a:srgbClr val="1A5C33"/>
+                </a:solidFill>
+              </a:defRPr>
+            </a:pPr>
+            <a:r>
+              <a:t>Learning Objectives</a:t>
+            </a:r>
+          </a:p>
+        </p:txBody>
+      </p:sp>
+      <p:sp>
+        <p:nvSpPr>
+          <p:cNvPr id="4" name="TextBox 3"/>
+          <p:cNvSpPr txBox="1"/>
+          <p:nvPr/>
+        </p:nvSpPr>
+        <p:spPr>
+          <a:xfrm>
+            <a:off x="457200" y="1371600"/>
+            <a:ext cx="7772400" cy="4572000"/>
+          </a:xfrm>
+          <a:prstGeom prst="rect">
+            <a:avLst/>
+          </a:prstGeom>
+          <a:noFill/>
+        </p:spPr>
+        <p:txBody>
+          <a:bodyPr wrap="square">
+            <a:spAutoFit/>
+          </a:bodyPr>
+          <a:lstStyle/>
+          <a:p>
+            <a:pPr>
+              <a:spcAft>
+                <a:spcPts val="600"/>
+              </a:spcAft>
+              <a:defRPr sz="1400">
+                <a:solidFill>
+                  <a:srgbClr val="222222"/>
+                </a:solidFill>
+              </a:defRPr>
+            </a:pPr>
+            <a:r>
+              <a:t>• Knowledge:- Define ICT and its evolution</a:t>
+            </a:r>
+            <a:br/>
+            <a:r>
+              <a:t>- Distinguish technical, information, and communication dimensions</a:t>
+            </a:r>
+            <a:br/>
+            <a:r>
+              <a:t>- Understand pedagogical ICT integration in language didactics</a:t>
+            </a:r>
+          </a:p>
+          <a:p>
+            <a:pPr>
+              <a:spcAft>
+                <a:spcPts val="600"/>
+              </a:spcAft>
+              <a:defRPr sz="1400">
+                <a:solidFill>
+                  <a:srgbClr val="222222"/>
+                </a:solidFill>
+              </a:defRPr>
+            </a:pPr>
+            <a:r>
+              <a:t>• Skills:- Use ICT tools to design teaching sequences</a:t>
+            </a:r>
+            <a:br/>
+            <a:r>
+              <a:t>- Evaluate and select digital resources for the classroom</a:t>
+            </a:r>
+            <a:br/>
+            <a:r>
+              <a:t>- Create interactive teaching materials</a:t>
+            </a:r>
+          </a:p>
+          <a:p>
+            <a:pPr>
+              <a:spcAft>
+                <a:spcPts val="600"/>
+              </a:spcAft>
+              <a:defRPr sz="1400">
+                <a:solidFill>
+                  <a:srgbClr val="222222"/>
+                </a:solidFill>
+              </a:defRPr>
+            </a:pPr>
+            <a:r>
+              <a:t>• Attitudes:- Adopt a digital mediator posture in the classroom</a:t>
+            </a:r>
+            <a:br/>
+            <a:r>
+              <a:t>- Develop critical thinking about tools and resources</a:t>
             </a:r>
           </a:p>
         </p:txBody>
@@ -4651,9 +4737,935 @@
   <p:clrMapOvr>
     <a:masterClrMapping/>
   </p:clrMapOvr>
-  <p:transition spd="med">
-    <p:fade/>
-  </p:transition>
+</p:sld>
+</file>
+
+<file path=ppt/slides/slide5.xml><?xml version="1.0" encoding="utf-8"?>
+<p:sld xmlns:a="http://schemas.openxmlformats.org/drawingml/2006/main" xmlns:p="http://schemas.openxmlformats.org/presentationml/2006/main" xmlns:r="http://schemas.openxmlformats.org/officeDocument/2006/relationships">
+  <p:cSld>
+    <p:bg>
+      <p:bgPr>
+        <a:solidFill>
+          <a:srgbClr val="FFFFFF"/>
+        </a:solidFill>
+        <a:effectLst/>
+      </p:bgPr>
+    </p:bg>
+    <p:spTree>
+      <p:nvGrpSpPr>
+        <p:cNvPr id="1" name=""/>
+        <p:cNvGrpSpPr/>
+        <p:nvPr/>
+      </p:nvGrpSpPr>
+      <p:grpSpPr/>
+      <p:sp>
+        <p:nvSpPr>
+          <p:cNvPr id="2" name="Rectangle 1"/>
+          <p:cNvSpPr/>
+          <p:nvPr/>
+        </p:nvSpPr>
+        <p:spPr>
+          <a:xfrm>
+            <a:off x="0" y="0"/>
+            <a:ext cx="109728" cy="6858000"/>
+          </a:xfrm>
+          <a:prstGeom prst="rect">
+            <a:avLst/>
+          </a:prstGeom>
+          <a:solidFill>
+            <a:srgbClr val="2C6E49"/>
+          </a:solidFill>
+          <a:ln>
+            <a:noFill/>
+          </a:ln>
+        </p:spPr>
+        <p:style>
+          <a:lnRef idx="1">
+            <a:schemeClr val="accent1"/>
+          </a:lnRef>
+          <a:fillRef idx="3">
+            <a:schemeClr val="accent1"/>
+          </a:fillRef>
+          <a:effectRef idx="2">
+            <a:schemeClr val="accent1"/>
+          </a:effectRef>
+          <a:fontRef idx="minor">
+            <a:schemeClr val="lt1"/>
+          </a:fontRef>
+        </p:style>
+        <p:txBody>
+          <a:bodyPr rtlCol="0" anchor="ctr"/>
+          <a:lstStyle/>
+          <a:p>
+            <a:pPr algn="ctr"/>
+          </a:p>
+        </p:txBody>
+      </p:sp>
+      <p:sp>
+        <p:nvSpPr>
+          <p:cNvPr id="3" name="TextBox 2"/>
+          <p:cNvSpPr txBox="1"/>
+          <p:nvPr/>
+        </p:nvSpPr>
+        <p:spPr>
+          <a:xfrm>
+            <a:off x="457200" y="365760"/>
+            <a:ext cx="8229600" cy="640080"/>
+          </a:xfrm>
+          <a:prstGeom prst="rect">
+            <a:avLst/>
+          </a:prstGeom>
+          <a:noFill/>
+        </p:spPr>
+        <p:txBody>
+          <a:bodyPr wrap="square">
+            <a:spAutoFit/>
+          </a:bodyPr>
+          <a:lstStyle/>
+          <a:p>
+            <a:pPr algn="l">
+              <a:defRPr sz="2200" b="1">
+                <a:solidFill>
+                  <a:srgbClr val="1A5C33"/>
+                </a:solidFill>
+              </a:defRPr>
+            </a:pPr>
+            <a:r>
+              <a:t>1. Definition and Evolution(10 min)</a:t>
+            </a:r>
+          </a:p>
+        </p:txBody>
+      </p:sp>
+      <p:sp>
+        <p:nvSpPr>
+          <p:cNvPr id="4" name="TextBox 3"/>
+          <p:cNvSpPr txBox="1"/>
+          <p:nvPr/>
+        </p:nvSpPr>
+        <p:spPr>
+          <a:xfrm>
+            <a:off x="457200" y="1371600"/>
+            <a:ext cx="7772400" cy="4572000"/>
+          </a:xfrm>
+          <a:prstGeom prst="rect">
+            <a:avLst/>
+          </a:prstGeom>
+          <a:noFill/>
+        </p:spPr>
+        <p:txBody>
+          <a:bodyPr wrap="square">
+            <a:spAutoFit/>
+          </a:bodyPr>
+          <a:lstStyle/>
+          <a:p>
+            <a:pPr>
+              <a:spcAft>
+                <a:spcPts val="600"/>
+              </a:spcAft>
+              <a:defRPr sz="1400">
+                <a:solidFill>
+                  <a:srgbClr val="222222"/>
+                </a:solidFill>
+              </a:defRPr>
+            </a:pPr>
+            <a:r>
+              <a:t>• ICTcovers digital tools and systems for creating, processing, storing, transmitting, and sharing information.</a:t>
+            </a:r>
+          </a:p>
+          <a:p>
+            <a:pPr>
+              <a:spcAft>
+                <a:spcPts val="600"/>
+              </a:spcAft>
+              <a:defRPr sz="1400">
+                <a:solidFill>
+                  <a:srgbClr val="222222"/>
+                </a:solidFill>
+              </a:defRPr>
+            </a:pPr>
+            <a:r>
+              <a:t>• Evolution:NTIC (1990-2005) → ICT (2005-present) → AI and EdTech (2020+).</a:t>
+            </a:r>
+          </a:p>
+          <a:p>
+            <a:pPr>
+              <a:spcAft>
+                <a:spcPts val="600"/>
+              </a:spcAft>
+              <a:defRPr sz="1400">
+                <a:solidFill>
+                  <a:srgbClr val="222222"/>
+                </a:solidFill>
+              </a:defRPr>
+            </a:pPr>
+            <a:r>
+              <a:t>• For the future teacher:ICT are not just personal tools butpedagogical instrumentsto integrate into teaching practice.</a:t>
+            </a:r>
+          </a:p>
+        </p:txBody>
+      </p:sp>
+    </p:spTree>
+  </p:cSld>
+  <p:clrMapOvr>
+    <a:masterClrMapping/>
+  </p:clrMapOvr>
+</p:sld>
+</file>
+
+<file path=ppt/slides/slide6.xml><?xml version="1.0" encoding="utf-8"?>
+<p:sld xmlns:a="http://schemas.openxmlformats.org/drawingml/2006/main" xmlns:p="http://schemas.openxmlformats.org/presentationml/2006/main" xmlns:r="http://schemas.openxmlformats.org/officeDocument/2006/relationships">
+  <p:cSld>
+    <p:bg>
+      <p:bgPr>
+        <a:solidFill>
+          <a:srgbClr val="FFFFFF"/>
+        </a:solidFill>
+        <a:effectLst/>
+      </p:bgPr>
+    </p:bg>
+    <p:spTree>
+      <p:nvGrpSpPr>
+        <p:cNvPr id="1" name=""/>
+        <p:cNvGrpSpPr/>
+        <p:nvPr/>
+      </p:nvGrpSpPr>
+      <p:grpSpPr/>
+      <p:sp>
+        <p:nvSpPr>
+          <p:cNvPr id="2" name="Rectangle 1"/>
+          <p:cNvSpPr/>
+          <p:nvPr/>
+        </p:nvSpPr>
+        <p:spPr>
+          <a:xfrm>
+            <a:off x="0" y="0"/>
+            <a:ext cx="109728" cy="6858000"/>
+          </a:xfrm>
+          <a:prstGeom prst="rect">
+            <a:avLst/>
+          </a:prstGeom>
+          <a:solidFill>
+            <a:srgbClr val="2C6E49"/>
+          </a:solidFill>
+          <a:ln>
+            <a:noFill/>
+          </a:ln>
+        </p:spPr>
+        <p:style>
+          <a:lnRef idx="1">
+            <a:schemeClr val="accent1"/>
+          </a:lnRef>
+          <a:fillRef idx="3">
+            <a:schemeClr val="accent1"/>
+          </a:fillRef>
+          <a:effectRef idx="2">
+            <a:schemeClr val="accent1"/>
+          </a:effectRef>
+          <a:fontRef idx="minor">
+            <a:schemeClr val="lt1"/>
+          </a:fontRef>
+        </p:style>
+        <p:txBody>
+          <a:bodyPr rtlCol="0" anchor="ctr"/>
+          <a:lstStyle/>
+          <a:p>
+            <a:pPr algn="ctr"/>
+          </a:p>
+        </p:txBody>
+      </p:sp>
+      <p:sp>
+        <p:nvSpPr>
+          <p:cNvPr id="3" name="TextBox 2"/>
+          <p:cNvSpPr txBox="1"/>
+          <p:nvPr/>
+        </p:nvSpPr>
+        <p:spPr>
+          <a:xfrm>
+            <a:off x="457200" y="365760"/>
+            <a:ext cx="8229600" cy="640080"/>
+          </a:xfrm>
+          <a:prstGeom prst="rect">
+            <a:avLst/>
+          </a:prstGeom>
+          <a:noFill/>
+        </p:spPr>
+        <p:txBody>
+          <a:bodyPr wrap="square">
+            <a:spAutoFit/>
+          </a:bodyPr>
+          <a:lstStyle/>
+          <a:p>
+            <a:pPr algn="l">
+              <a:defRPr sz="2200" b="1">
+                <a:solidFill>
+                  <a:srgbClr val="1A5C33"/>
+                </a:solidFill>
+              </a:defRPr>
+            </a:pPr>
+            <a:r>
+              <a:t>3. ICT and Pedagogy(20 min)</a:t>
+            </a:r>
+          </a:p>
+        </p:txBody>
+      </p:sp>
+      <p:sp>
+        <p:nvSpPr>
+          <p:cNvPr id="4" name="TextBox 3"/>
+          <p:cNvSpPr txBox="1"/>
+          <p:nvPr/>
+        </p:nvSpPr>
+        <p:spPr>
+          <a:xfrm>
+            <a:off x="457200" y="1371600"/>
+            <a:ext cx="7772400" cy="4572000"/>
+          </a:xfrm>
+          <a:prstGeom prst="rect">
+            <a:avLst/>
+          </a:prstGeom>
+          <a:noFill/>
+        </p:spPr>
+        <p:txBody>
+          <a:bodyPr wrap="square">
+            <a:spAutoFit/>
+          </a:bodyPr>
+          <a:lstStyle/>
+          <a:p>
+            <a:pPr>
+              <a:spcAft>
+                <a:spcPts val="600"/>
+              </a:spcAft>
+              <a:defRPr sz="1400">
+                <a:solidFill>
+                  <a:srgbClr val="222222"/>
+                </a:solidFill>
+              </a:defRPr>
+            </a:pPr>
+            <a:r>
+              <a:t>• Why integrate ICT in language teaching?- Learner motivation and engagement</a:t>
+            </a:r>
+            <a:br/>
+            <a:r>
+              <a:t>- Access to authentic resources (videos, articles, podcasts)</a:t>
+            </a:r>
+            <a:br/>
+            <a:r>
+              <a:t>- Individualized learning paths</a:t>
+            </a:r>
+            <a:br/>
+            <a:r>
+              <a:t>- Autonomy development</a:t>
+            </a:r>
+          </a:p>
+          <a:p>
+            <a:pPr>
+              <a:spcAft>
+                <a:spcPts val="600"/>
+              </a:spcAft>
+              <a:defRPr sz="1400">
+                <a:solidFill>
+                  <a:srgbClr val="222222"/>
+                </a:solidFill>
+              </a:defRPr>
+            </a:pPr>
+            <a:r>
+              <a:t>• Application areas:- Listening: podcasts, audio recording</a:t>
+            </a:r>
+            <a:br/>
+            <a:r>
+              <a:t>- Writing: blogs, wikis, collaborative editing</a:t>
+            </a:r>
+            <a:br/>
+            <a:r>
+              <a:t>- Interaction: videoconferencing with partner classes</a:t>
+            </a:r>
+            <a:br/>
+            <a:r>
+              <a:t>- Grammar/vocabulary: interactive exercises, quizzes</a:t>
+            </a:r>
+          </a:p>
+        </p:txBody>
+      </p:sp>
+    </p:spTree>
+  </p:cSld>
+  <p:clrMapOvr>
+    <a:masterClrMapping/>
+  </p:clrMapOvr>
+</p:sld>
+</file>
+
+<file path=ppt/slides/slide7.xml><?xml version="1.0" encoding="utf-8"?>
+<p:sld xmlns:a="http://schemas.openxmlformats.org/drawingml/2006/main" xmlns:p="http://schemas.openxmlformats.org/presentationml/2006/main" xmlns:r="http://schemas.openxmlformats.org/officeDocument/2006/relationships">
+  <p:cSld>
+    <p:bg>
+      <p:bgPr>
+        <a:solidFill>
+          <a:srgbClr val="FFFFFF"/>
+        </a:solidFill>
+        <a:effectLst/>
+      </p:bgPr>
+    </p:bg>
+    <p:spTree>
+      <p:nvGrpSpPr>
+        <p:cNvPr id="1" name=""/>
+        <p:cNvGrpSpPr/>
+        <p:nvPr/>
+      </p:nvGrpSpPr>
+      <p:grpSpPr/>
+      <p:sp>
+        <p:nvSpPr>
+          <p:cNvPr id="2" name="Rectangle 1"/>
+          <p:cNvSpPr/>
+          <p:nvPr/>
+        </p:nvSpPr>
+        <p:spPr>
+          <a:xfrm>
+            <a:off x="0" y="0"/>
+            <a:ext cx="109728" cy="6858000"/>
+          </a:xfrm>
+          <a:prstGeom prst="rect">
+            <a:avLst/>
+          </a:prstGeom>
+          <a:solidFill>
+            <a:srgbClr val="2C6E49"/>
+          </a:solidFill>
+          <a:ln>
+            <a:noFill/>
+          </a:ln>
+        </p:spPr>
+        <p:style>
+          <a:lnRef idx="1">
+            <a:schemeClr val="accent1"/>
+          </a:lnRef>
+          <a:fillRef idx="3">
+            <a:schemeClr val="accent1"/>
+          </a:fillRef>
+          <a:effectRef idx="2">
+            <a:schemeClr val="accent1"/>
+          </a:effectRef>
+          <a:fontRef idx="minor">
+            <a:schemeClr val="lt1"/>
+          </a:fontRef>
+        </p:style>
+        <p:txBody>
+          <a:bodyPr rtlCol="0" anchor="ctr"/>
+          <a:lstStyle/>
+          <a:p>
+            <a:pPr algn="ctr"/>
+          </a:p>
+        </p:txBody>
+      </p:sp>
+      <p:sp>
+        <p:nvSpPr>
+          <p:cNvPr id="3" name="TextBox 2"/>
+          <p:cNvSpPr txBox="1"/>
+          <p:nvPr/>
+        </p:nvSpPr>
+        <p:spPr>
+          <a:xfrm>
+            <a:off x="457200" y="365760"/>
+            <a:ext cx="8229600" cy="640080"/>
+          </a:xfrm>
+          <a:prstGeom prst="rect">
+            <a:avLst/>
+          </a:prstGeom>
+          <a:noFill/>
+        </p:spPr>
+        <p:txBody>
+          <a:bodyPr wrap="square">
+            <a:spAutoFit/>
+          </a:bodyPr>
+          <a:lstStyle/>
+          <a:p>
+            <a:pPr algn="l">
+              <a:defRPr sz="2200" b="1">
+                <a:solidFill>
+                  <a:srgbClr val="1A5C33"/>
+                </a:solidFill>
+              </a:defRPr>
+            </a:pPr>
+            <a:r>
+              <a:t>6. Teacher Digital Competencies(15 min)</a:t>
+            </a:r>
+          </a:p>
+        </p:txBody>
+      </p:sp>
+      <p:sp>
+        <p:nvSpPr>
+          <p:cNvPr id="4" name="TextBox 3"/>
+          <p:cNvSpPr txBox="1"/>
+          <p:nvPr/>
+        </p:nvSpPr>
+        <p:spPr>
+          <a:xfrm>
+            <a:off x="457200" y="1371600"/>
+            <a:ext cx="7772400" cy="4572000"/>
+          </a:xfrm>
+          <a:prstGeom prst="rect">
+            <a:avLst/>
+          </a:prstGeom>
+          <a:noFill/>
+        </p:spPr>
+        <p:txBody>
+          <a:bodyPr wrap="square">
+            <a:spAutoFit/>
+          </a:bodyPr>
+          <a:lstStyle/>
+          <a:p>
+            <a:pPr>
+              <a:spcAft>
+                <a:spcPts val="600"/>
+              </a:spcAft>
+              <a:defRPr sz="1400">
+                <a:solidFill>
+                  <a:srgbClr val="222222"/>
+                </a:solidFill>
+              </a:defRPr>
+            </a:pPr>
+            <a:r>
+              <a:t>• Design sequences integrating digital tools</a:t>
+            </a:r>
+          </a:p>
+          <a:p>
+            <a:pPr>
+              <a:spcAft>
+                <a:spcPts val="600"/>
+              </a:spcAft>
+              <a:defRPr sz="1400">
+                <a:solidFill>
+                  <a:srgbClr val="222222"/>
+                </a:solidFill>
+              </a:defRPr>
+            </a:pPr>
+            <a:r>
+              <a:t>• Implement collaborative online activities</a:t>
+            </a:r>
+          </a:p>
+          <a:p>
+            <a:pPr>
+              <a:spcAft>
+                <a:spcPts val="600"/>
+              </a:spcAft>
+              <a:defRPr sz="1400">
+                <a:solidFill>
+                  <a:srgbClr val="222222"/>
+                </a:solidFill>
+              </a:defRPr>
+            </a:pPr>
+            <a:r>
+              <a:t>• Assess with digital tools</a:t>
+            </a:r>
+          </a:p>
+          <a:p>
+            <a:pPr>
+              <a:spcAft>
+                <a:spcPts val="600"/>
+              </a:spcAft>
+              <a:defRPr sz="1400">
+                <a:solidFill>
+                  <a:srgbClr val="222222"/>
+                </a:solidFill>
+              </a:defRPr>
+            </a:pPr>
+            <a:r>
+              <a:t>• Ensure security and ethics</a:t>
+            </a:r>
+          </a:p>
+          <a:p>
+            <a:pPr>
+              <a:spcAft>
+                <a:spcPts val="600"/>
+              </a:spcAft>
+              <a:defRPr sz="1400">
+                <a:solidFill>
+                  <a:srgbClr val="222222"/>
+                </a:solidFill>
+              </a:defRPr>
+            </a:pPr>
+            <a:r>
+              <a:t>• Develop professional monitoring</a:t>
+            </a:r>
+          </a:p>
+        </p:txBody>
+      </p:sp>
+    </p:spTree>
+  </p:cSld>
+  <p:clrMapOvr>
+    <a:masterClrMapping/>
+  </p:clrMapOvr>
+</p:sld>
+</file>
+
+<file path=ppt/slides/slide8.xml><?xml version="1.0" encoding="utf-8"?>
+<p:sld xmlns:a="http://schemas.openxmlformats.org/drawingml/2006/main" xmlns:p="http://schemas.openxmlformats.org/presentationml/2006/main" xmlns:r="http://schemas.openxmlformats.org/officeDocument/2006/relationships">
+  <p:cSld>
+    <p:bg>
+      <p:bgPr>
+        <a:solidFill>
+          <a:srgbClr val="FFFFFF"/>
+        </a:solidFill>
+        <a:effectLst/>
+      </p:bgPr>
+    </p:bg>
+    <p:spTree>
+      <p:nvGrpSpPr>
+        <p:cNvPr id="1" name=""/>
+        <p:cNvGrpSpPr/>
+        <p:nvPr/>
+      </p:nvGrpSpPr>
+      <p:grpSpPr/>
+      <p:sp>
+        <p:nvSpPr>
+          <p:cNvPr id="2" name="Rectangle 1"/>
+          <p:cNvSpPr/>
+          <p:nvPr/>
+        </p:nvSpPr>
+        <p:spPr>
+          <a:xfrm>
+            <a:off x="0" y="0"/>
+            <a:ext cx="109728" cy="6858000"/>
+          </a:xfrm>
+          <a:prstGeom prst="rect">
+            <a:avLst/>
+          </a:prstGeom>
+          <a:solidFill>
+            <a:srgbClr val="2C6E49"/>
+          </a:solidFill>
+          <a:ln>
+            <a:noFill/>
+          </a:ln>
+        </p:spPr>
+        <p:style>
+          <a:lnRef idx="1">
+            <a:schemeClr val="accent1"/>
+          </a:lnRef>
+          <a:fillRef idx="3">
+            <a:schemeClr val="accent1"/>
+          </a:fillRef>
+          <a:effectRef idx="2">
+            <a:schemeClr val="accent1"/>
+          </a:effectRef>
+          <a:fontRef idx="minor">
+            <a:schemeClr val="lt1"/>
+          </a:fontRef>
+        </p:style>
+        <p:txBody>
+          <a:bodyPr rtlCol="0" anchor="ctr"/>
+          <a:lstStyle/>
+          <a:p>
+            <a:pPr algn="ctr"/>
+          </a:p>
+        </p:txBody>
+      </p:sp>
+      <p:sp>
+        <p:nvSpPr>
+          <p:cNvPr id="3" name="TextBox 2"/>
+          <p:cNvSpPr txBox="1"/>
+          <p:nvPr/>
+        </p:nvSpPr>
+        <p:spPr>
+          <a:xfrm>
+            <a:off x="457200" y="365760"/>
+            <a:ext cx="8229600" cy="640080"/>
+          </a:xfrm>
+          <a:prstGeom prst="rect">
+            <a:avLst/>
+          </a:prstGeom>
+          <a:noFill/>
+        </p:spPr>
+        <p:txBody>
+          <a:bodyPr wrap="square">
+            <a:spAutoFit/>
+          </a:bodyPr>
+          <a:lstStyle/>
+          <a:p>
+            <a:pPr algn="l">
+              <a:defRPr sz="2200" b="1">
+                <a:solidFill>
+                  <a:srgbClr val="1A5C33"/>
+                </a:solidFill>
+              </a:defRPr>
+            </a:pPr>
+            <a:r>
+              <a:t>7. Ethics and Security(10 min)</a:t>
+            </a:r>
+          </a:p>
+        </p:txBody>
+      </p:sp>
+      <p:sp>
+        <p:nvSpPr>
+          <p:cNvPr id="4" name="TextBox 3"/>
+          <p:cNvSpPr txBox="1"/>
+          <p:nvPr/>
+        </p:nvSpPr>
+        <p:spPr>
+          <a:xfrm>
+            <a:off x="457200" y="1371600"/>
+            <a:ext cx="7772400" cy="4572000"/>
+          </a:xfrm>
+          <a:prstGeom prst="rect">
+            <a:avLst/>
+          </a:prstGeom>
+          <a:noFill/>
+        </p:spPr>
+        <p:txBody>
+          <a:bodyPr wrap="square">
+            <a:spAutoFit/>
+          </a:bodyPr>
+          <a:lstStyle/>
+          <a:p>
+            <a:pPr>
+              <a:spcAft>
+                <a:spcPts val="600"/>
+              </a:spcAft>
+              <a:defRPr sz="1400">
+                <a:solidFill>
+                  <a:srgbClr val="222222"/>
+                </a:solidFill>
+              </a:defRPr>
+            </a:pPr>
+            <a:r>
+              <a:t>• GDPR compliance:protect student data</a:t>
+            </a:r>
+          </a:p>
+          <a:p>
+            <a:pPr>
+              <a:spcAft>
+                <a:spcPts val="600"/>
+              </a:spcAft>
+              <a:defRPr sz="1400">
+                <a:solidFill>
+                  <a:srgbClr val="222222"/>
+                </a:solidFill>
+              </a:defRPr>
+            </a:pPr>
+            <a:r>
+              <a:t>• Copyright:use open-licensed resources (Creative Commons)</a:t>
+            </a:r>
+          </a:p>
+          <a:p>
+            <a:pPr>
+              <a:spcAft>
+                <a:spcPts val="600"/>
+              </a:spcAft>
+              <a:defRPr sz="1400">
+                <a:solidFill>
+                  <a:srgbClr val="222222"/>
+                </a:solidFill>
+              </a:defRPr>
+            </a:pPr>
+            <a:r>
+              <a:t>• Cyberbullying:prevention in class</a:t>
+            </a:r>
+          </a:p>
+          <a:p>
+            <a:pPr>
+              <a:spcAft>
+                <a:spcPts val="600"/>
+              </a:spcAft>
+              <a:defRPr sz="1400">
+                <a:solidFill>
+                  <a:srgbClr val="222222"/>
+                </a:solidFill>
+              </a:defRPr>
+            </a:pPr>
+            <a:r>
+              <a:t>• Digital identity:the teacher as a role model</a:t>
+            </a:r>
+          </a:p>
+        </p:txBody>
+      </p:sp>
+    </p:spTree>
+  </p:cSld>
+  <p:clrMapOvr>
+    <a:masterClrMapping/>
+  </p:clrMapOvr>
+</p:sld>
+</file>
+
+<file path=ppt/slides/slide9.xml><?xml version="1.0" encoding="utf-8"?>
+<p:sld xmlns:a="http://schemas.openxmlformats.org/drawingml/2006/main" xmlns:p="http://schemas.openxmlformats.org/presentationml/2006/main" xmlns:r="http://schemas.openxmlformats.org/officeDocument/2006/relationships">
+  <p:cSld>
+    <p:bg>
+      <p:bgPr>
+        <a:solidFill>
+          <a:srgbClr val="FFFFFF"/>
+        </a:solidFill>
+        <a:effectLst/>
+      </p:bgPr>
+    </p:bg>
+    <p:spTree>
+      <p:nvGrpSpPr>
+        <p:cNvPr id="1" name=""/>
+        <p:cNvGrpSpPr/>
+        <p:nvPr/>
+      </p:nvGrpSpPr>
+      <p:grpSpPr/>
+      <p:sp>
+        <p:nvSpPr>
+          <p:cNvPr id="2" name="Rectangle 1"/>
+          <p:cNvSpPr/>
+          <p:nvPr/>
+        </p:nvSpPr>
+        <p:spPr>
+          <a:xfrm>
+            <a:off x="0" y="0"/>
+            <a:ext cx="109728" cy="6858000"/>
+          </a:xfrm>
+          <a:prstGeom prst="rect">
+            <a:avLst/>
+          </a:prstGeom>
+          <a:solidFill>
+            <a:srgbClr val="2C6E49"/>
+          </a:solidFill>
+          <a:ln>
+            <a:noFill/>
+          </a:ln>
+        </p:spPr>
+        <p:style>
+          <a:lnRef idx="1">
+            <a:schemeClr val="accent1"/>
+          </a:lnRef>
+          <a:fillRef idx="3">
+            <a:schemeClr val="accent1"/>
+          </a:fillRef>
+          <a:effectRef idx="2">
+            <a:schemeClr val="accent1"/>
+          </a:effectRef>
+          <a:fontRef idx="minor">
+            <a:schemeClr val="lt1"/>
+          </a:fontRef>
+        </p:style>
+        <p:txBody>
+          <a:bodyPr rtlCol="0" anchor="ctr"/>
+          <a:lstStyle/>
+          <a:p>
+            <a:pPr algn="ctr"/>
+          </a:p>
+        </p:txBody>
+      </p:sp>
+      <p:sp>
+        <p:nvSpPr>
+          <p:cNvPr id="3" name="TextBox 2"/>
+          <p:cNvSpPr txBox="1"/>
+          <p:nvPr/>
+        </p:nvSpPr>
+        <p:spPr>
+          <a:xfrm>
+            <a:off x="457200" y="365760"/>
+            <a:ext cx="8229600" cy="640080"/>
+          </a:xfrm>
+          <a:prstGeom prst="rect">
+            <a:avLst/>
+          </a:prstGeom>
+          <a:noFill/>
+        </p:spPr>
+        <p:txBody>
+          <a:bodyPr wrap="square">
+            <a:spAutoFit/>
+          </a:bodyPr>
+          <a:lstStyle/>
+          <a:p>
+            <a:pPr algn="l">
+              <a:defRPr sz="2200" b="1">
+                <a:solidFill>
+                  <a:srgbClr val="1A5C33"/>
+                </a:solidFill>
+              </a:defRPr>
+            </a:pPr>
+            <a:r>
+              <a:t>8. Conclusion(5 min)</a:t>
+            </a:r>
+          </a:p>
+        </p:txBody>
+      </p:sp>
+      <p:sp>
+        <p:nvSpPr>
+          <p:cNvPr id="4" name="TextBox 3"/>
+          <p:cNvSpPr txBox="1"/>
+          <p:nvPr/>
+        </p:nvSpPr>
+        <p:spPr>
+          <a:xfrm>
+            <a:off x="457200" y="1371600"/>
+            <a:ext cx="7772400" cy="4572000"/>
+          </a:xfrm>
+          <a:prstGeom prst="rect">
+            <a:avLst/>
+          </a:prstGeom>
+          <a:noFill/>
+        </p:spPr>
+        <p:txBody>
+          <a:bodyPr wrap="square">
+            <a:spAutoFit/>
+          </a:bodyPr>
+          <a:lstStyle/>
+          <a:p>
+            <a:pPr>
+              <a:spcAft>
+                <a:spcPts val="600"/>
+              </a:spcAft>
+              <a:defRPr sz="1400">
+                <a:solidFill>
+                  <a:srgbClr val="222222"/>
+                </a:solidFill>
+              </a:defRPr>
+            </a:pPr>
+            <a:r>
+              <a:t>• ICT are apedagogical leverfor language teachers</a:t>
+            </a:r>
+          </a:p>
+          <a:p>
+            <a:pPr>
+              <a:spcAft>
+                <a:spcPts val="600"/>
+              </a:spcAft>
+              <a:defRPr sz="1400">
+                <a:solidFill>
+                  <a:srgbClr val="222222"/>
+                </a:solidFill>
+              </a:defRPr>
+            </a:pPr>
+            <a:r>
+              <a:t>• Integration must bethoughtful(SAMR model)</a:t>
+            </a:r>
+          </a:p>
+          <a:p>
+            <a:pPr>
+              <a:spcAft>
+                <a:spcPts val="600"/>
+              </a:spcAft>
+              <a:defRPr sz="1400">
+                <a:solidFill>
+                  <a:srgbClr val="222222"/>
+                </a:solidFill>
+              </a:defRPr>
+            </a:pPr>
+            <a:r>
+              <a:t>• Future teachers must developdigital competencies</a:t>
+            </a:r>
+          </a:p>
+          <a:p>
+            <a:pPr>
+              <a:spcAft>
+                <a:spcPts val="600"/>
+              </a:spcAft>
+              <a:defRPr sz="1400">
+                <a:solidFill>
+                  <a:srgbClr val="222222"/>
+                </a:solidFill>
+              </a:defRPr>
+            </a:pPr>
+            <a:r>
+              <a:t>• TD 01(1h30) — analyzing ICT tools for the classroom.</a:t>
+            </a:r>
+          </a:p>
+        </p:txBody>
+      </p:sp>
+    </p:spTree>
+  </p:cSld>
+  <p:clrMapOvr>
+    <a:masterClrMapping/>
+  </p:clrMapOvr>
 </p:sld>
 </file>
 
@@ -4975,319 +5987,4 @@
   </a:objectDefaults>
   <a:extraClrSchemeLst/>
 </a:theme>
-</file>
-
-<file path=ppt/theme/theme2.xml><?xml version="1.0" encoding="utf-8"?>
-<a:theme xmlns:a="http://schemas.openxmlformats.org/drawingml/2006/main" name="Thème Office">
-  <a:themeElements>
-    <a:clrScheme name="Office">
-      <a:dk1>
-        <a:sysClr val="windowText" lastClr="000000"/>
-      </a:dk1>
-      <a:lt1>
-        <a:sysClr val="window" lastClr="FFFFFF"/>
-      </a:lt1>
-      <a:dk2>
-        <a:srgbClr val="0E2841"/>
-      </a:dk2>
-      <a:lt2>
-        <a:srgbClr val="E8E8E8"/>
-      </a:lt2>
-      <a:accent1>
-        <a:srgbClr val="156082"/>
-      </a:accent1>
-      <a:accent2>
-        <a:srgbClr val="E97132"/>
-      </a:accent2>
-      <a:accent3>
-        <a:srgbClr val="196B24"/>
-      </a:accent3>
-      <a:accent4>
-        <a:srgbClr val="0F9ED5"/>
-      </a:accent4>
-      <a:accent5>
-        <a:srgbClr val="A02B93"/>
-      </a:accent5>
-      <a:accent6>
-        <a:srgbClr val="4EA72E"/>
-      </a:accent6>
-      <a:hlink>
-        <a:srgbClr val="467886"/>
-      </a:hlink>
-      <a:folHlink>
-        <a:srgbClr val="96607D"/>
-      </a:folHlink>
-    </a:clrScheme>
-    <a:fontScheme name="Office">
-      <a:majorFont>
-        <a:latin typeface="Aptos Display" panose="02110004020202020204"/>
-        <a:ea typeface=""/>
-        <a:cs typeface=""/>
-        <a:font script="Jpan" typeface="游ゴシック Light"/>
-        <a:font script="Hang" typeface="맑은 고딕"/>
-        <a:font script="Hans" typeface="等线 Light"/>
-        <a:font script="Hant" typeface="新細明體"/>
-        <a:font script="Arab" typeface="Times New Roman"/>
-        <a:font script="Hebr" typeface="Times New Roman"/>
-        <a:font script="Thai" typeface="Angsana New"/>
-        <a:font script="Ethi" typeface="Nyala"/>
-        <a:font script="Beng" typeface="Vrinda"/>
-        <a:font script="Gujr" typeface="Shruti"/>
-        <a:font script="Khmr" typeface="MoolBoran"/>
-        <a:font script="Knda" typeface="Tunga"/>
-        <a:font script="Guru" typeface="Raavi"/>
-        <a:font script="Cans" typeface="Euphemia"/>
-        <a:font script="Cher" typeface="Plantagenet Cherokee"/>
-        <a:font script="Yiii" typeface="Microsoft Yi Baiti"/>
-        <a:font script="Tibt" typeface="Microsoft Himalaya"/>
-        <a:font script="Thaa" typeface="MV Boli"/>
-        <a:font script="Deva" typeface="Mangal"/>
-        <a:font script="Telu" typeface="Gautami"/>
-        <a:font script="Taml" typeface="Latha"/>
-        <a:font script="Syrc" typeface="Estrangelo Edessa"/>
-        <a:font script="Orya" typeface="Kalinga"/>
-        <a:font script="Mlym" typeface="Kartika"/>
-        <a:font script="Laoo" typeface="DokChampa"/>
-        <a:font script="Sinh" typeface="Iskoola Pota"/>
-        <a:font script="Mong" typeface="Mongolian Baiti"/>
-        <a:font script="Viet" typeface="Times New Roman"/>
-        <a:font script="Uigh" typeface="Microsoft Uighur"/>
-        <a:font script="Geor" typeface="Sylfaen"/>
-        <a:font script="Armn" typeface="Arial"/>
-        <a:font script="Bugi" typeface="Leelawadee UI"/>
-        <a:font script="Bopo" typeface="Microsoft JhengHei"/>
-        <a:font script="Java" typeface="Javanese Text"/>
-        <a:font script="Lisu" typeface="Segoe UI"/>
-        <a:font script="Mymr" typeface="Myanmar Text"/>
-        <a:font script="Nkoo" typeface="Ebrima"/>
-        <a:font script="Olck" typeface="Nirmala UI"/>
-        <a:font script="Osma" typeface="Ebrima"/>
-        <a:font script="Phag" typeface="Phagspa"/>
-        <a:font script="Syrn" typeface="Estrangelo Edessa"/>
-        <a:font script="Syrj" typeface="Estrangelo Edessa"/>
-        <a:font script="Syre" typeface="Estrangelo Edessa"/>
-        <a:font script="Sora" typeface="Nirmala UI"/>
-        <a:font script="Tale" typeface="Microsoft Tai Le"/>
-        <a:font script="Talu" typeface="Microsoft New Tai Lue"/>
-        <a:font script="Tfng" typeface="Ebrima"/>
-      </a:majorFont>
-      <a:minorFont>
-        <a:latin typeface="Aptos" panose="02110004020202020204"/>
-        <a:ea typeface=""/>
-        <a:cs typeface=""/>
-        <a:font script="Jpan" typeface="游ゴシック"/>
-        <a:font script="Hang" typeface="맑은 고딕"/>
-        <a:font script="Hans" typeface="等线"/>
-        <a:font script="Hant" typeface="新細明體"/>
-        <a:font script="Arab" typeface="Arial"/>
-        <a:font script="Hebr" typeface="Arial"/>
-        <a:font script="Thai" typeface="Cordia New"/>
-        <a:font script="Ethi" typeface="Nyala"/>
-        <a:font script="Beng" typeface="Vrinda"/>
-        <a:font script="Gujr" typeface="Shruti"/>
-        <a:font script="Khmr" typeface="DaunPenh"/>
-        <a:font script="Knda" typeface="Tunga"/>
-        <a:font script="Guru" typeface="Raavi"/>
-        <a:font script="Cans" typeface="Euphemia"/>
-        <a:font script="Cher" typeface="Plantagenet Cherokee"/>
-        <a:font script="Yiii" typeface="Microsoft Yi Baiti"/>
-        <a:font script="Tibt" typeface="Microsoft Himalaya"/>
-        <a:font script="Thaa" typeface="MV Boli"/>
-        <a:font script="Deva" typeface="Mangal"/>
-        <a:font script="Telu" typeface="Gautami"/>
-        <a:font script="Taml" typeface="Latha"/>
-        <a:font script="Syrc" typeface="Estrangelo Edessa"/>
-        <a:font script="Orya" typeface="Kalinga"/>
-        <a:font script="Mlym" typeface="Kartika"/>
-        <a:font script="Laoo" typeface="DokChampa"/>
-        <a:font script="Sinh" typeface="Iskoola Pota"/>
-        <a:font script="Mong" typeface="Mongolian Baiti"/>
-        <a:font script="Viet" typeface="Arial"/>
-        <a:font script="Uigh" typeface="Microsoft Uighur"/>
-        <a:font script="Geor" typeface="Sylfaen"/>
-        <a:font script="Armn" typeface="Arial"/>
-        <a:font script="Bugi" typeface="Leelawadee UI"/>
-        <a:font script="Bopo" typeface="Microsoft JhengHei"/>
-        <a:font script="Java" typeface="Javanese Text"/>
-        <a:font script="Lisu" typeface="Segoe UI"/>
-        <a:font script="Mymr" typeface="Myanmar Text"/>
-        <a:font script="Nkoo" typeface="Ebrima"/>
-        <a:font script="Olck" typeface="Nirmala UI"/>
-        <a:font script="Osma" typeface="Ebrima"/>
-        <a:font script="Phag" typeface="Phagspa"/>
-        <a:font script="Syrn" typeface="Estrangelo Edessa"/>
-        <a:font script="Syrj" typeface="Estrangelo Edessa"/>
-        <a:font script="Syre" typeface="Estrangelo Edessa"/>
-        <a:font script="Sora" typeface="Nirmala UI"/>
-        <a:font script="Tale" typeface="Microsoft Tai Le"/>
-        <a:font script="Talu" typeface="Microsoft New Tai Lue"/>
-        <a:font script="Tfng" typeface="Ebrima"/>
-      </a:minorFont>
-    </a:fontScheme>
-    <a:fmtScheme name="Office">
-      <a:fillStyleLst>
-        <a:solidFill>
-          <a:schemeClr val="phClr"/>
-        </a:solidFill>
-        <a:gradFill rotWithShape="1">
-          <a:gsLst>
-            <a:gs pos="0">
-              <a:schemeClr val="phClr">
-                <a:lumMod val="110000"/>
-                <a:satMod val="105000"/>
-                <a:tint val="67000"/>
-              </a:schemeClr>
-            </a:gs>
-            <a:gs pos="50000">
-              <a:schemeClr val="phClr">
-                <a:lumMod val="105000"/>
-                <a:satMod val="103000"/>
-                <a:tint val="73000"/>
-              </a:schemeClr>
-            </a:gs>
-            <a:gs pos="100000">
-              <a:schemeClr val="phClr">
-                <a:lumMod val="105000"/>
-                <a:satMod val="109000"/>
-                <a:tint val="81000"/>
-              </a:schemeClr>
-            </a:gs>
-          </a:gsLst>
-          <a:lin ang="5400000" scaled="0"/>
-        </a:gradFill>
-        <a:gradFill rotWithShape="1">
-          <a:gsLst>
-            <a:gs pos="0">
-              <a:schemeClr val="phClr">
-                <a:satMod val="103000"/>
-                <a:lumMod val="102000"/>
-                <a:tint val="94000"/>
-              </a:schemeClr>
-            </a:gs>
-            <a:gs pos="50000">
-              <a:schemeClr val="phClr">
-                <a:satMod val="110000"/>
-                <a:lumMod val="100000"/>
-                <a:shade val="100000"/>
-              </a:schemeClr>
-            </a:gs>
-            <a:gs pos="100000">
-              <a:schemeClr val="phClr">
-                <a:lumMod val="99000"/>
-                <a:satMod val="120000"/>
-                <a:shade val="78000"/>
-              </a:schemeClr>
-            </a:gs>
-          </a:gsLst>
-          <a:lin ang="5400000" scaled="0"/>
-        </a:gradFill>
-      </a:fillStyleLst>
-      <a:lnStyleLst>
-        <a:ln w="12700" cap="flat" cmpd="sng" algn="ctr">
-          <a:solidFill>
-            <a:schemeClr val="phClr"/>
-          </a:solidFill>
-          <a:prstDash val="solid"/>
-          <a:miter lim="800000"/>
-        </a:ln>
-        <a:ln w="19050" cap="flat" cmpd="sng" algn="ctr">
-          <a:solidFill>
-            <a:schemeClr val="phClr"/>
-          </a:solidFill>
-          <a:prstDash val="solid"/>
-          <a:miter lim="800000"/>
-        </a:ln>
-        <a:ln w="25400" cap="flat" cmpd="sng" algn="ctr">
-          <a:solidFill>
-            <a:schemeClr val="phClr"/>
-          </a:solidFill>
-          <a:prstDash val="solid"/>
-          <a:miter lim="800000"/>
-        </a:ln>
-      </a:lnStyleLst>
-      <a:effectStyleLst>
-        <a:effectStyle>
-          <a:effectLst/>
-        </a:effectStyle>
-        <a:effectStyle>
-          <a:effectLst/>
-        </a:effectStyle>
-        <a:effectStyle>
-          <a:effectLst>
-            <a:outerShdw blurRad="57150" dist="19050" dir="5400000" algn="ctr" rotWithShape="0">
-              <a:srgbClr val="000000">
-                <a:alpha val="63000"/>
-              </a:srgbClr>
-            </a:outerShdw>
-          </a:effectLst>
-        </a:effectStyle>
-      </a:effectStyleLst>
-      <a:bgFillStyleLst>
-        <a:solidFill>
-          <a:schemeClr val="phClr"/>
-        </a:solidFill>
-        <a:solidFill>
-          <a:schemeClr val="phClr">
-            <a:tint val="95000"/>
-            <a:satMod val="170000"/>
-          </a:schemeClr>
-        </a:solidFill>
-        <a:gradFill rotWithShape="1">
-          <a:gsLst>
-            <a:gs pos="0">
-              <a:schemeClr val="phClr">
-                <a:tint val="93000"/>
-                <a:satMod val="150000"/>
-                <a:shade val="98000"/>
-                <a:lumMod val="102000"/>
-              </a:schemeClr>
-            </a:gs>
-            <a:gs pos="50000">
-              <a:schemeClr val="phClr">
-                <a:tint val="98000"/>
-                <a:satMod val="130000"/>
-                <a:shade val="90000"/>
-                <a:lumMod val="103000"/>
-              </a:schemeClr>
-            </a:gs>
-            <a:gs pos="100000">
-              <a:schemeClr val="phClr">
-                <a:shade val="63000"/>
-                <a:satMod val="120000"/>
-              </a:schemeClr>
-            </a:gs>
-          </a:gsLst>
-          <a:lin ang="5400000" scaled="0"/>
-        </a:gradFill>
-      </a:bgFillStyleLst>
-    </a:fmtScheme>
-  </a:themeElements>
-  <a:objectDefaults>
-    <a:lnDef>
-      <a:spPr/>
-      <a:bodyPr/>
-      <a:lstStyle/>
-      <a:style>
-        <a:lnRef idx="2">
-          <a:schemeClr val="accent1"/>
-        </a:lnRef>
-        <a:fillRef idx="0">
-          <a:schemeClr val="accent1"/>
-        </a:fillRef>
-        <a:effectRef idx="1">
-          <a:schemeClr val="accent1"/>
-        </a:effectRef>
-        <a:fontRef idx="minor">
-          <a:schemeClr val="tx1"/>
-        </a:fontRef>
-      </a:style>
-    </a:lnDef>
-  </a:objectDefaults>
-  <a:extraClrSchemeLst/>
-  <a:extLst>
-    <a:ext uri="{05A4C25C-085E-4340-85A3-A5531E510DB2}">
-      <thm15:themeFamily xmlns:thm15="http://schemas.microsoft.com/office/thememl/2012/main" name="Office Theme" id="{2E142A2C-CD16-42D6-873A-C26D2A0506FA}" vid="{1BDDFF52-6CD6-40A5-AB3C-68EB2F1E4D0A}"/>
-    </a:ext>
-  </a:extLst>
-</a:theme>
 </file>
</xml_diff>